<commit_message>
Deployed a5f6242 with MkDocs version: 1.6.1
</commit_message>
<xml_diff>
--- a/situation_report_features.pptx
+++ b/situation_report_features.pptx
@@ -12,6 +12,7 @@
     <p:sldId id="260" r:id="rId11"/>
     <p:sldId id="261" r:id="rId12"/>
     <p:sldId id="262" r:id="rId13"/>
+    <p:sldId id="263" r:id="rId14"/>
   </p:sldIdLst>
   <p:sldSz cx="12188952" cy="6858000" type="screen4x3"/>
   <p:notesSz cx="6858000" cy="9144000"/>
@@ -3243,7 +3244,7 @@
                   <a:srgbClr val="ECF0F1"/>
                 </a:solidFill>
               </a:rPr>
-              <a:t>Feature-Übersicht — Stand April 2026</a:t>
+              <a:t>Feature-Übersicht — v0.8.4 | Stand April 2026</a:t>
             </a:r>
           </a:p>
         </p:txBody>
@@ -3372,7 +3373,7 @@
                   <a:srgbClr val="FFFFFF"/>
                 </a:solidFill>
               </a:rPr>
-              <a:t>transform_data</a:t>
+              <a:t>launcher — Zentraler Einstiegspunkt</a:t>
             </a:r>
           </a:p>
         </p:txBody>
@@ -3646,7 +3647,7 @@
                   <a:srgbClr val="2C3E50"/>
                 </a:solidFill>
               </a:rPr>
-              <a:t>Kern-Transformation</a:t>
+              <a:t>Modul-Grid</a:t>
             </a:r>
           </a:p>
         </p:txBody>
@@ -3680,7 +3681,7 @@
                   <a:srgbClr val="2C3E50"/>
                 </a:solidFill>
               </a:rPr>
-              <a:t>Liest Jira-JSON-Export, berechnet Verweildauer je Workflow-Stage, schreibt IssueTimes.xlsx und CFD.xlsx</a:t>
+              <a:t>Alle verfügbaren und geplanten Module als Kacheln; verfügbare Module per Klick direkt starten — öffnen sich als eigenständiger Prozess in eigenem Fenster, Launcher bleibt geöffnet</a:t>
             </a:r>
           </a:p>
         </p:txBody>
@@ -3800,7 +3801,7 @@
                   <a:srgbClr val="2C3E50"/>
                 </a:solidFill>
               </a:rPr>
-              <a:t>Workflow-Datei</a:t>
+              <a:t>5 Sprachen</a:t>
             </a:r>
           </a:p>
         </p:txBody>
@@ -3834,7 +3835,7 @@
                   <a:srgbClr val="2C3E50"/>
                 </a:solidFill>
               </a:rPr>
-              <a:t>Textdatei mit &lt;First&gt;- und &lt;Closed&gt;-Markern definiert Eintritts- und Abschluss-Stage</a:t>
+              <a:t>Vollständig lokalisiert in DE, EN, RO, PT, FR — Umschaltung per Flag-Button oben rechts; Einstellung wird persistent gespeichert und gilt für alle Module gemeinsam</a:t>
             </a:r>
           </a:p>
         </p:txBody>
@@ -3954,7 +3955,7 @@
                   <a:srgbClr val="2C3E50"/>
                 </a:solidFill>
               </a:rPr>
-              <a:t>Datumsregeln</a:t>
+              <a:t>Update-Check</a:t>
             </a:r>
           </a:p>
         </p:txBody>
@@ -3988,7 +3989,7 @@
                   <a:srgbClr val="2C3E50"/>
                 </a:solidFill>
               </a:rPr>
-              <a:t>First Date / Closed Date aus Stage-Übergängen; Fallback bei übersprungenen Stages; Closed Date wird gelöscht wenn Issue wiedereröffnet wurde</a:t>
+              <a:t>Beim Start automatische Prüfung auf neue GitHub-Releases im Hintergrund; gelbes Banner mit Download-Link erscheint bei neuerer Version — kein Fehler bei fehlendem Internet</a:t>
             </a:r>
           </a:p>
         </p:txBody>
@@ -4108,7 +4109,7 @@
                   <a:srgbClr val="2C3E50"/>
                 </a:solidFill>
               </a:rPr>
-              <a:t>Carry-Forward</a:t>
+              <a:t>Handbuch-Button</a:t>
             </a:r>
           </a:p>
         </p:txBody>
@@ -4142,7 +4143,7 @@
                   <a:srgbClr val="2C3E50"/>
                 </a:solidFill>
               </a:rPr>
-              <a:t>Verweildauer wird auf letzte bekannte Stage weitergezählt wenn eine Stage übersprungen wurde</a:t>
+              <a:t>(?)-Button öffnet sprachspezifisches PDF-Handbuch direkt auf GitHub Pages — in allen 5 Sprachen verfügbar</a:t>
             </a:r>
           </a:p>
         </p:txBody>
@@ -4262,7 +4263,7 @@
                   <a:srgbClr val="2C3E50"/>
                 </a:solidFill>
               </a:rPr>
-              <a:t>Validierung &amp; Warnungen</a:t>
+              <a:t>ALPHA-Badge</a:t>
             </a:r>
           </a:p>
         </p:txBody>
@@ -4296,7 +4297,7 @@
                   <a:srgbClr val="2C3E50"/>
                 </a:solidFill>
               </a:rPr>
-              <a:t>Warnt bei fehlenden Workflow-Markern, unmapped Statuses und Stage-Inkonsistenzen</a:t>
+              <a:t>Rotes ALPHA-Badge in der Titelleiste signalisiert Alpha-Status des Projekts</a:t>
             </a:r>
           </a:p>
         </p:txBody>
@@ -4416,7 +4417,7 @@
                   <a:srgbClr val="2C3E50"/>
                 </a:solidFill>
               </a:rPr>
-              <a:t>GUI</a:t>
+              <a:t>Portable Start</a:t>
             </a:r>
           </a:p>
         </p:txBody>
@@ -4450,7 +4451,7 @@
                   <a:srgbClr val="2C3E50"/>
                 </a:solidFill>
               </a:rPr>
-              <a:t>tkinter-Oberfläche mit Dateidialogen für JSON, Workflow-Datei und Ausgabeordner; Präfix automatisch aus Dateiname vorbelegt</a:t>
+              <a:t>SituationReport.bat (Windows) / .command (macOS) / .sh (Linux) — kein Python oder Terminal erforderlich</a:t>
             </a:r>
           </a:p>
         </p:txBody>
@@ -4458,314 +4459,6 @@
       <p:sp>
         <p:nvSpPr>
           <p:cNvPr id="32" name="Rectangle 31"/>
-          <p:cNvSpPr/>
-          <p:nvPr/>
-        </p:nvSpPr>
-        <p:spPr>
-          <a:xfrm>
-            <a:off x="274320" y="5276087"/>
-            <a:ext cx="2926080" cy="658368"/>
-          </a:xfrm>
-          <a:prstGeom prst="rect">
-            <a:avLst/>
-          </a:prstGeom>
-          <a:solidFill>
-            <a:srgbClr val="ECF0F1"/>
-          </a:solidFill>
-          <a:ln>
-            <a:noFill/>
-          </a:ln>
-        </p:spPr>
-        <p:style>
-          <a:lnRef idx="1">
-            <a:schemeClr val="accent1"/>
-          </a:lnRef>
-          <a:fillRef idx="3">
-            <a:schemeClr val="accent1"/>
-          </a:fillRef>
-          <a:effectRef idx="2">
-            <a:schemeClr val="accent1"/>
-          </a:effectRef>
-          <a:fontRef idx="minor">
-            <a:schemeClr val="lt1"/>
-          </a:fontRef>
-        </p:style>
-        <p:txBody>
-          <a:bodyPr rtlCol="0" anchor="ctr"/>
-          <a:lstStyle/>
-          <a:p>
-            <a:pPr algn="ctr"/>
-          </a:p>
-        </p:txBody>
-      </p:sp>
-      <p:sp>
-        <p:nvSpPr>
-          <p:cNvPr id="33" name="Rectangle 32"/>
-          <p:cNvSpPr/>
-          <p:nvPr/>
-        </p:nvSpPr>
-        <p:spPr>
-          <a:xfrm>
-            <a:off x="3291840" y="5276087"/>
-            <a:ext cx="8595360" cy="658368"/>
-          </a:xfrm>
-          <a:prstGeom prst="rect">
-            <a:avLst/>
-          </a:prstGeom>
-          <a:solidFill>
-            <a:srgbClr val="ECF0F1"/>
-          </a:solidFill>
-          <a:ln>
-            <a:noFill/>
-          </a:ln>
-        </p:spPr>
-        <p:style>
-          <a:lnRef idx="1">
-            <a:schemeClr val="accent1"/>
-          </a:lnRef>
-          <a:fillRef idx="3">
-            <a:schemeClr val="accent1"/>
-          </a:fillRef>
-          <a:effectRef idx="2">
-            <a:schemeClr val="accent1"/>
-          </a:effectRef>
-          <a:fontRef idx="minor">
-            <a:schemeClr val="lt1"/>
-          </a:fontRef>
-        </p:style>
-        <p:txBody>
-          <a:bodyPr rtlCol="0" anchor="ctr"/>
-          <a:lstStyle/>
-          <a:p>
-            <a:pPr algn="ctr"/>
-          </a:p>
-        </p:txBody>
-      </p:sp>
-      <p:sp>
-        <p:nvSpPr>
-          <p:cNvPr id="34" name="TextBox 33"/>
-          <p:cNvSpPr txBox="1"/>
-          <p:nvPr/>
-        </p:nvSpPr>
-        <p:spPr>
-          <a:xfrm>
-            <a:off x="347472" y="5312663"/>
-            <a:ext cx="2788920" cy="603503"/>
-          </a:xfrm>
-          <a:prstGeom prst="rect">
-            <a:avLst/>
-          </a:prstGeom>
-          <a:noFill/>
-        </p:spPr>
-        <p:txBody>
-          <a:bodyPr wrap="square">
-            <a:spAutoFit/>
-          </a:bodyPr>
-          <a:lstStyle/>
-          <a:p>
-            <a:pPr algn="l"/>
-            <a:r>
-              <a:rPr sz="900" b="1">
-                <a:solidFill>
-                  <a:srgbClr val="2C3E50"/>
-                </a:solidFill>
-              </a:rPr>
-              <a:t>Ladebalken</a:t>
-            </a:r>
-          </a:p>
-        </p:txBody>
-      </p:sp>
-      <p:sp>
-        <p:nvSpPr>
-          <p:cNvPr id="35" name="TextBox 34"/>
-          <p:cNvSpPr txBox="1"/>
-          <p:nvPr/>
-        </p:nvSpPr>
-        <p:spPr>
-          <a:xfrm>
-            <a:off x="3364992" y="5312663"/>
-            <a:ext cx="8412480" cy="603503"/>
-          </a:xfrm>
-          <a:prstGeom prst="rect">
-            <a:avLst/>
-          </a:prstGeom>
-          <a:noFill/>
-        </p:spPr>
-        <p:txBody>
-          <a:bodyPr wrap="square">
-            <a:spAutoFit/>
-          </a:bodyPr>
-          <a:lstStyle/>
-          <a:p>
-            <a:pPr algn="l"/>
-            <a:r>
-              <a:rPr sz="900" b="0">
-                <a:solidFill>
-                  <a:srgbClr val="2C3E50"/>
-                </a:solidFill>
-              </a:rPr>
-              <a:t>Erscheint nach 3 Sekunden wenn die Transformation noch läuft</a:t>
-            </a:r>
-          </a:p>
-        </p:txBody>
-      </p:sp>
-      <p:sp>
-        <p:nvSpPr>
-          <p:cNvPr id="36" name="Rectangle 35"/>
-          <p:cNvSpPr/>
-          <p:nvPr/>
-        </p:nvSpPr>
-        <p:spPr>
-          <a:xfrm>
-            <a:off x="274320" y="5934455"/>
-            <a:ext cx="2926080" cy="658368"/>
-          </a:xfrm>
-          <a:prstGeom prst="rect">
-            <a:avLst/>
-          </a:prstGeom>
-          <a:solidFill>
-            <a:srgbClr val="FFFFFF"/>
-          </a:solidFill>
-          <a:ln>
-            <a:noFill/>
-          </a:ln>
-        </p:spPr>
-        <p:style>
-          <a:lnRef idx="1">
-            <a:schemeClr val="accent1"/>
-          </a:lnRef>
-          <a:fillRef idx="3">
-            <a:schemeClr val="accent1"/>
-          </a:fillRef>
-          <a:effectRef idx="2">
-            <a:schemeClr val="accent1"/>
-          </a:effectRef>
-          <a:fontRef idx="minor">
-            <a:schemeClr val="lt1"/>
-          </a:fontRef>
-        </p:style>
-        <p:txBody>
-          <a:bodyPr rtlCol="0" anchor="ctr"/>
-          <a:lstStyle/>
-          <a:p>
-            <a:pPr algn="ctr"/>
-          </a:p>
-        </p:txBody>
-      </p:sp>
-      <p:sp>
-        <p:nvSpPr>
-          <p:cNvPr id="37" name="Rectangle 36"/>
-          <p:cNvSpPr/>
-          <p:nvPr/>
-        </p:nvSpPr>
-        <p:spPr>
-          <a:xfrm>
-            <a:off x="3291840" y="5934455"/>
-            <a:ext cx="8595360" cy="658368"/>
-          </a:xfrm>
-          <a:prstGeom prst="rect">
-            <a:avLst/>
-          </a:prstGeom>
-          <a:solidFill>
-            <a:srgbClr val="FFFFFF"/>
-          </a:solidFill>
-          <a:ln>
-            <a:noFill/>
-          </a:ln>
-        </p:spPr>
-        <p:style>
-          <a:lnRef idx="1">
-            <a:schemeClr val="accent1"/>
-          </a:lnRef>
-          <a:fillRef idx="3">
-            <a:schemeClr val="accent1"/>
-          </a:fillRef>
-          <a:effectRef idx="2">
-            <a:schemeClr val="accent1"/>
-          </a:effectRef>
-          <a:fontRef idx="minor">
-            <a:schemeClr val="lt1"/>
-          </a:fontRef>
-        </p:style>
-        <p:txBody>
-          <a:bodyPr rtlCol="0" anchor="ctr"/>
-          <a:lstStyle/>
-          <a:p>
-            <a:pPr algn="ctr"/>
-          </a:p>
-        </p:txBody>
-      </p:sp>
-      <p:sp>
-        <p:nvSpPr>
-          <p:cNvPr id="38" name="TextBox 37"/>
-          <p:cNvSpPr txBox="1"/>
-          <p:nvPr/>
-        </p:nvSpPr>
-        <p:spPr>
-          <a:xfrm>
-            <a:off x="347472" y="5971031"/>
-            <a:ext cx="2788920" cy="603503"/>
-          </a:xfrm>
-          <a:prstGeom prst="rect">
-            <a:avLst/>
-          </a:prstGeom>
-          <a:noFill/>
-        </p:spPr>
-        <p:txBody>
-          <a:bodyPr wrap="square">
-            <a:spAutoFit/>
-          </a:bodyPr>
-          <a:lstStyle/>
-          <a:p>
-            <a:pPr algn="l"/>
-            <a:r>
-              <a:rPr sz="900" b="1">
-                <a:solidFill>
-                  <a:srgbClr val="2C3E50"/>
-                </a:solidFill>
-              </a:rPr>
-              <a:t>Doppelklick-Starter</a:t>
-            </a:r>
-          </a:p>
-        </p:txBody>
-      </p:sp>
-      <p:sp>
-        <p:nvSpPr>
-          <p:cNvPr id="39" name="TextBox 38"/>
-          <p:cNvSpPr txBox="1"/>
-          <p:nvPr/>
-        </p:nvSpPr>
-        <p:spPr>
-          <a:xfrm>
-            <a:off x="3364992" y="5971031"/>
-            <a:ext cx="8412480" cy="603503"/>
-          </a:xfrm>
-          <a:prstGeom prst="rect">
-            <a:avLst/>
-          </a:prstGeom>
-          <a:noFill/>
-        </p:spPr>
-        <p:txBody>
-          <a:bodyPr wrap="square">
-            <a:spAutoFit/>
-          </a:bodyPr>
-          <a:lstStyle/>
-          <a:p>
-            <a:pPr algn="l"/>
-            <a:r>
-              <a:rPr sz="900" b="0">
-                <a:solidFill>
-                  <a:srgbClr val="2C3E50"/>
-                </a:solidFill>
-              </a:rPr>
-              <a:t>transform_data_gui.pyw startet die GUI ohne Konsolenfenster</a:t>
-            </a:r>
-          </a:p>
-        </p:txBody>
-      </p:sp>
-      <p:sp>
-        <p:nvSpPr>
-          <p:cNvPr id="40" name="Rectangle 39"/>
           <p:cNvSpPr/>
           <p:nvPr/>
         </p:nvSpPr>
@@ -4896,7 +4589,7 @@
                   <a:srgbClr val="FFFFFF"/>
                 </a:solidFill>
               </a:rPr>
-              <a:t>build_reports — Metriken</a:t>
+              <a:t>transform_data</a:t>
             </a:r>
           </a:p>
         </p:txBody>
@@ -5170,7 +4863,7 @@
                   <a:srgbClr val="2C3E50"/>
                 </a:solidFill>
               </a:rPr>
-              <a:t>Flow Time / Cycle Time</a:t>
+              <a:t>Kern-Transformation</a:t>
             </a:r>
           </a:p>
         </p:txBody>
@@ -5204,7 +4897,7 @@
                   <a:srgbClr val="2C3E50"/>
                 </a:solidFill>
               </a:rPr>
-              <a:t>Boxplot + Scatterplot; Methode A &amp; B; LOESS-Trendlinie; Perzentil-Referenzlinien; farbige Punkte; rote Ausreißer; Issue-Key als Hover-Tooltip</a:t>
+              <a:t>Liest Jira-JSON-Export, berechnet Verweildauer je Workflow-Stage, schreibt IssueTimes.xlsx und CFD.xlsx</a:t>
             </a:r>
           </a:p>
         </p:txBody>
@@ -5324,7 +5017,7 @@
                   <a:srgbClr val="2C3E50"/>
                 </a:solidFill>
               </a:rPr>
-              <a:t>Flow Velocity / Throughput</a:t>
+              <a:t>Workflow-Datei</a:t>
             </a:r>
           </a:p>
         </p:txBody>
@@ -5358,7 +5051,7 @@
                   <a:srgbClr val="2C3E50"/>
                 </a:solidFill>
               </a:rPr>
-              <a:t>Tagesfrequenz-Histogramm + Wochenverlauf-Linienchart + PI-Balkendiagramm; konfigurierbares Target CT</a:t>
+              <a:t>Textdatei mit &lt;First&gt;- und &lt;Closed&gt;-Markern definiert Eintritts- und Abschluss-Stage</a:t>
             </a:r>
           </a:p>
         </p:txBody>
@@ -5478,7 +5171,7 @@
                   <a:srgbClr val="2C3E50"/>
                 </a:solidFill>
               </a:rPr>
-              <a:t>Flow Load / WIP</a:t>
+              <a:t>Datumsregeln</a:t>
             </a:r>
           </a:p>
         </p:txBody>
@@ -5512,7 +5205,7 @@
                   <a:srgbClr val="2C3E50"/>
                 </a:solidFill>
               </a:rPr>
-              <a:t>Aging-WIP-Boxplot pro Stage; Issue-Anzahl je Stage als Annotation; Referenzlinien (Median, P85, Target CT); Legende</a:t>
+              <a:t>First Date / Closed Date aus Stage-Übergängen; Fallback bei übersprungenen Stages; Closed Date wird gelöscht wenn Issue wiedereröffnet wurde</a:t>
             </a:r>
           </a:p>
         </p:txBody>
@@ -5632,7 +5325,7 @@
                   <a:srgbClr val="2C3E50"/>
                 </a:solidFill>
               </a:rPr>
-              <a:t>CFD</a:t>
+              <a:t>Carry-Forward</a:t>
             </a:r>
           </a:p>
         </p:txBody>
@@ -5666,7 +5359,7 @@
                   <a:srgbClr val="2C3E50"/>
                 </a:solidFill>
               </a:rPr>
-              <a:t>Gestapeltes Flächendiagramm; Trendlinien an visuellen Oberkanten der &lt;First&gt;- und &lt;Closed&gt;-Stages; Monats-/KW-Achse ohne Überlappung; In/Out-Ratio im Titel</a:t>
+              <a:t>Verweildauer wird auf letzte bekannte Stage weitergezählt wenn eine Stage übersprungen wurde</a:t>
             </a:r>
           </a:p>
         </p:txBody>
@@ -5786,7 +5479,7 @@
                   <a:srgbClr val="2C3E50"/>
                 </a:solidFill>
               </a:rPr>
-              <a:t>Flow Distribution</a:t>
+              <a:t>Validierung &amp; Warnungen</a:t>
             </a:r>
           </a:p>
         </p:txBody>
@@ -5820,7 +5513,7 @@
                   <a:srgbClr val="2C3E50"/>
                 </a:solidFill>
               </a:rPr>
-              <a:t>Drei Teildiagramme: Issue-Typ-Donut, Stage-Prominence-Donut, Ø Cycle Time je Typ als Balken</a:t>
+              <a:t>Warnt bei fehlenden Workflow-Markern, unmapped Statuses und Stage-Inkonsistenzen</a:t>
             </a:r>
           </a:p>
         </p:txBody>
@@ -5828,6 +5521,468 @@
       <p:sp>
         <p:nvSpPr>
           <p:cNvPr id="28" name="Rectangle 27"/>
+          <p:cNvSpPr/>
+          <p:nvPr/>
+        </p:nvSpPr>
+        <p:spPr>
+          <a:xfrm>
+            <a:off x="274320" y="4617719"/>
+            <a:ext cx="2926080" cy="658368"/>
+          </a:xfrm>
+          <a:prstGeom prst="rect">
+            <a:avLst/>
+          </a:prstGeom>
+          <a:solidFill>
+            <a:srgbClr val="FFFFFF"/>
+          </a:solidFill>
+          <a:ln>
+            <a:noFill/>
+          </a:ln>
+        </p:spPr>
+        <p:style>
+          <a:lnRef idx="1">
+            <a:schemeClr val="accent1"/>
+          </a:lnRef>
+          <a:fillRef idx="3">
+            <a:schemeClr val="accent1"/>
+          </a:fillRef>
+          <a:effectRef idx="2">
+            <a:schemeClr val="accent1"/>
+          </a:effectRef>
+          <a:fontRef idx="minor">
+            <a:schemeClr val="lt1"/>
+          </a:fontRef>
+        </p:style>
+        <p:txBody>
+          <a:bodyPr rtlCol="0" anchor="ctr"/>
+          <a:lstStyle/>
+          <a:p>
+            <a:pPr algn="ctr"/>
+          </a:p>
+        </p:txBody>
+      </p:sp>
+      <p:sp>
+        <p:nvSpPr>
+          <p:cNvPr id="29" name="Rectangle 28"/>
+          <p:cNvSpPr/>
+          <p:nvPr/>
+        </p:nvSpPr>
+        <p:spPr>
+          <a:xfrm>
+            <a:off x="3291840" y="4617719"/>
+            <a:ext cx="8595360" cy="658368"/>
+          </a:xfrm>
+          <a:prstGeom prst="rect">
+            <a:avLst/>
+          </a:prstGeom>
+          <a:solidFill>
+            <a:srgbClr val="FFFFFF"/>
+          </a:solidFill>
+          <a:ln>
+            <a:noFill/>
+          </a:ln>
+        </p:spPr>
+        <p:style>
+          <a:lnRef idx="1">
+            <a:schemeClr val="accent1"/>
+          </a:lnRef>
+          <a:fillRef idx="3">
+            <a:schemeClr val="accent1"/>
+          </a:fillRef>
+          <a:effectRef idx="2">
+            <a:schemeClr val="accent1"/>
+          </a:effectRef>
+          <a:fontRef idx="minor">
+            <a:schemeClr val="lt1"/>
+          </a:fontRef>
+        </p:style>
+        <p:txBody>
+          <a:bodyPr rtlCol="0" anchor="ctr"/>
+          <a:lstStyle/>
+          <a:p>
+            <a:pPr algn="ctr"/>
+          </a:p>
+        </p:txBody>
+      </p:sp>
+      <p:sp>
+        <p:nvSpPr>
+          <p:cNvPr id="30" name="TextBox 29"/>
+          <p:cNvSpPr txBox="1"/>
+          <p:nvPr/>
+        </p:nvSpPr>
+        <p:spPr>
+          <a:xfrm>
+            <a:off x="347472" y="4654295"/>
+            <a:ext cx="2788920" cy="603503"/>
+          </a:xfrm>
+          <a:prstGeom prst="rect">
+            <a:avLst/>
+          </a:prstGeom>
+          <a:noFill/>
+        </p:spPr>
+        <p:txBody>
+          <a:bodyPr wrap="square">
+            <a:spAutoFit/>
+          </a:bodyPr>
+          <a:lstStyle/>
+          <a:p>
+            <a:pPr algn="l"/>
+            <a:r>
+              <a:rPr sz="900" b="1">
+                <a:solidFill>
+                  <a:srgbClr val="2C3E50"/>
+                </a:solidFill>
+              </a:rPr>
+              <a:t>GUI</a:t>
+            </a:r>
+          </a:p>
+        </p:txBody>
+      </p:sp>
+      <p:sp>
+        <p:nvSpPr>
+          <p:cNvPr id="31" name="TextBox 30"/>
+          <p:cNvSpPr txBox="1"/>
+          <p:nvPr/>
+        </p:nvSpPr>
+        <p:spPr>
+          <a:xfrm>
+            <a:off x="3364992" y="4654295"/>
+            <a:ext cx="8412480" cy="603503"/>
+          </a:xfrm>
+          <a:prstGeom prst="rect">
+            <a:avLst/>
+          </a:prstGeom>
+          <a:noFill/>
+        </p:spPr>
+        <p:txBody>
+          <a:bodyPr wrap="square">
+            <a:spAutoFit/>
+          </a:bodyPr>
+          <a:lstStyle/>
+          <a:p>
+            <a:pPr algn="l"/>
+            <a:r>
+              <a:rPr sz="900" b="0">
+                <a:solidFill>
+                  <a:srgbClr val="2C3E50"/>
+                </a:solidFill>
+              </a:rPr>
+              <a:t>tkinter-Oberfläche mit Dateidialogen für JSON, Workflow-Datei und Ausgabeordner; Präfix automatisch aus Dateiname vorbelegt</a:t>
+            </a:r>
+          </a:p>
+        </p:txBody>
+      </p:sp>
+      <p:sp>
+        <p:nvSpPr>
+          <p:cNvPr id="32" name="Rectangle 31"/>
+          <p:cNvSpPr/>
+          <p:nvPr/>
+        </p:nvSpPr>
+        <p:spPr>
+          <a:xfrm>
+            <a:off x="274320" y="5276087"/>
+            <a:ext cx="2926080" cy="658368"/>
+          </a:xfrm>
+          <a:prstGeom prst="rect">
+            <a:avLst/>
+          </a:prstGeom>
+          <a:solidFill>
+            <a:srgbClr val="ECF0F1"/>
+          </a:solidFill>
+          <a:ln>
+            <a:noFill/>
+          </a:ln>
+        </p:spPr>
+        <p:style>
+          <a:lnRef idx="1">
+            <a:schemeClr val="accent1"/>
+          </a:lnRef>
+          <a:fillRef idx="3">
+            <a:schemeClr val="accent1"/>
+          </a:fillRef>
+          <a:effectRef idx="2">
+            <a:schemeClr val="accent1"/>
+          </a:effectRef>
+          <a:fontRef idx="minor">
+            <a:schemeClr val="lt1"/>
+          </a:fontRef>
+        </p:style>
+        <p:txBody>
+          <a:bodyPr rtlCol="0" anchor="ctr"/>
+          <a:lstStyle/>
+          <a:p>
+            <a:pPr algn="ctr"/>
+          </a:p>
+        </p:txBody>
+      </p:sp>
+      <p:sp>
+        <p:nvSpPr>
+          <p:cNvPr id="33" name="Rectangle 32"/>
+          <p:cNvSpPr/>
+          <p:nvPr/>
+        </p:nvSpPr>
+        <p:spPr>
+          <a:xfrm>
+            <a:off x="3291840" y="5276087"/>
+            <a:ext cx="8595360" cy="658368"/>
+          </a:xfrm>
+          <a:prstGeom prst="rect">
+            <a:avLst/>
+          </a:prstGeom>
+          <a:solidFill>
+            <a:srgbClr val="ECF0F1"/>
+          </a:solidFill>
+          <a:ln>
+            <a:noFill/>
+          </a:ln>
+        </p:spPr>
+        <p:style>
+          <a:lnRef idx="1">
+            <a:schemeClr val="accent1"/>
+          </a:lnRef>
+          <a:fillRef idx="3">
+            <a:schemeClr val="accent1"/>
+          </a:fillRef>
+          <a:effectRef idx="2">
+            <a:schemeClr val="accent1"/>
+          </a:effectRef>
+          <a:fontRef idx="minor">
+            <a:schemeClr val="lt1"/>
+          </a:fontRef>
+        </p:style>
+        <p:txBody>
+          <a:bodyPr rtlCol="0" anchor="ctr"/>
+          <a:lstStyle/>
+          <a:p>
+            <a:pPr algn="ctr"/>
+          </a:p>
+        </p:txBody>
+      </p:sp>
+      <p:sp>
+        <p:nvSpPr>
+          <p:cNvPr id="34" name="TextBox 33"/>
+          <p:cNvSpPr txBox="1"/>
+          <p:nvPr/>
+        </p:nvSpPr>
+        <p:spPr>
+          <a:xfrm>
+            <a:off x="347472" y="5312663"/>
+            <a:ext cx="2788920" cy="603503"/>
+          </a:xfrm>
+          <a:prstGeom prst="rect">
+            <a:avLst/>
+          </a:prstGeom>
+          <a:noFill/>
+        </p:spPr>
+        <p:txBody>
+          <a:bodyPr wrap="square">
+            <a:spAutoFit/>
+          </a:bodyPr>
+          <a:lstStyle/>
+          <a:p>
+            <a:pPr algn="l"/>
+            <a:r>
+              <a:rPr sz="900" b="1">
+                <a:solidFill>
+                  <a:srgbClr val="2C3E50"/>
+                </a:solidFill>
+              </a:rPr>
+              <a:t>Ladebalken</a:t>
+            </a:r>
+          </a:p>
+        </p:txBody>
+      </p:sp>
+      <p:sp>
+        <p:nvSpPr>
+          <p:cNvPr id="35" name="TextBox 34"/>
+          <p:cNvSpPr txBox="1"/>
+          <p:nvPr/>
+        </p:nvSpPr>
+        <p:spPr>
+          <a:xfrm>
+            <a:off x="3364992" y="5312663"/>
+            <a:ext cx="8412480" cy="603503"/>
+          </a:xfrm>
+          <a:prstGeom prst="rect">
+            <a:avLst/>
+          </a:prstGeom>
+          <a:noFill/>
+        </p:spPr>
+        <p:txBody>
+          <a:bodyPr wrap="square">
+            <a:spAutoFit/>
+          </a:bodyPr>
+          <a:lstStyle/>
+          <a:p>
+            <a:pPr algn="l"/>
+            <a:r>
+              <a:rPr sz="900" b="0">
+                <a:solidFill>
+                  <a:srgbClr val="2C3E50"/>
+                </a:solidFill>
+              </a:rPr>
+              <a:t>Erscheint nach 3 Sekunden wenn die Transformation noch läuft</a:t>
+            </a:r>
+          </a:p>
+        </p:txBody>
+      </p:sp>
+      <p:sp>
+        <p:nvSpPr>
+          <p:cNvPr id="36" name="Rectangle 35"/>
+          <p:cNvSpPr/>
+          <p:nvPr/>
+        </p:nvSpPr>
+        <p:spPr>
+          <a:xfrm>
+            <a:off x="274320" y="5934455"/>
+            <a:ext cx="2926080" cy="658368"/>
+          </a:xfrm>
+          <a:prstGeom prst="rect">
+            <a:avLst/>
+          </a:prstGeom>
+          <a:solidFill>
+            <a:srgbClr val="FFFFFF"/>
+          </a:solidFill>
+          <a:ln>
+            <a:noFill/>
+          </a:ln>
+        </p:spPr>
+        <p:style>
+          <a:lnRef idx="1">
+            <a:schemeClr val="accent1"/>
+          </a:lnRef>
+          <a:fillRef idx="3">
+            <a:schemeClr val="accent1"/>
+          </a:fillRef>
+          <a:effectRef idx="2">
+            <a:schemeClr val="accent1"/>
+          </a:effectRef>
+          <a:fontRef idx="minor">
+            <a:schemeClr val="lt1"/>
+          </a:fontRef>
+        </p:style>
+        <p:txBody>
+          <a:bodyPr rtlCol="0" anchor="ctr"/>
+          <a:lstStyle/>
+          <a:p>
+            <a:pPr algn="ctr"/>
+          </a:p>
+        </p:txBody>
+      </p:sp>
+      <p:sp>
+        <p:nvSpPr>
+          <p:cNvPr id="37" name="Rectangle 36"/>
+          <p:cNvSpPr/>
+          <p:nvPr/>
+        </p:nvSpPr>
+        <p:spPr>
+          <a:xfrm>
+            <a:off x="3291840" y="5934455"/>
+            <a:ext cx="8595360" cy="658368"/>
+          </a:xfrm>
+          <a:prstGeom prst="rect">
+            <a:avLst/>
+          </a:prstGeom>
+          <a:solidFill>
+            <a:srgbClr val="FFFFFF"/>
+          </a:solidFill>
+          <a:ln>
+            <a:noFill/>
+          </a:ln>
+        </p:spPr>
+        <p:style>
+          <a:lnRef idx="1">
+            <a:schemeClr val="accent1"/>
+          </a:lnRef>
+          <a:fillRef idx="3">
+            <a:schemeClr val="accent1"/>
+          </a:fillRef>
+          <a:effectRef idx="2">
+            <a:schemeClr val="accent1"/>
+          </a:effectRef>
+          <a:fontRef idx="minor">
+            <a:schemeClr val="lt1"/>
+          </a:fontRef>
+        </p:style>
+        <p:txBody>
+          <a:bodyPr rtlCol="0" anchor="ctr"/>
+          <a:lstStyle/>
+          <a:p>
+            <a:pPr algn="ctr"/>
+          </a:p>
+        </p:txBody>
+      </p:sp>
+      <p:sp>
+        <p:nvSpPr>
+          <p:cNvPr id="38" name="TextBox 37"/>
+          <p:cNvSpPr txBox="1"/>
+          <p:nvPr/>
+        </p:nvSpPr>
+        <p:spPr>
+          <a:xfrm>
+            <a:off x="347472" y="5971031"/>
+            <a:ext cx="2788920" cy="603503"/>
+          </a:xfrm>
+          <a:prstGeom prst="rect">
+            <a:avLst/>
+          </a:prstGeom>
+          <a:noFill/>
+        </p:spPr>
+        <p:txBody>
+          <a:bodyPr wrap="square">
+            <a:spAutoFit/>
+          </a:bodyPr>
+          <a:lstStyle/>
+          <a:p>
+            <a:pPr algn="l"/>
+            <a:r>
+              <a:rPr sz="900" b="1">
+                <a:solidFill>
+                  <a:srgbClr val="2C3E50"/>
+                </a:solidFill>
+              </a:rPr>
+              <a:t>Doppelklick-Starter</a:t>
+            </a:r>
+          </a:p>
+        </p:txBody>
+      </p:sp>
+      <p:sp>
+        <p:nvSpPr>
+          <p:cNvPr id="39" name="TextBox 38"/>
+          <p:cNvSpPr txBox="1"/>
+          <p:nvPr/>
+        </p:nvSpPr>
+        <p:spPr>
+          <a:xfrm>
+            <a:off x="3364992" y="5971031"/>
+            <a:ext cx="8412480" cy="603503"/>
+          </a:xfrm>
+          <a:prstGeom prst="rect">
+            <a:avLst/>
+          </a:prstGeom>
+          <a:noFill/>
+        </p:spPr>
+        <p:txBody>
+          <a:bodyPr wrap="square">
+            <a:spAutoFit/>
+          </a:bodyPr>
+          <a:lstStyle/>
+          <a:p>
+            <a:pPr algn="l"/>
+            <a:r>
+              <a:rPr sz="900" b="0">
+                <a:solidFill>
+                  <a:srgbClr val="2C3E50"/>
+                </a:solidFill>
+              </a:rPr>
+              <a:t>transform_data_gui.pyw startet die GUI ohne Konsolenfenster</a:t>
+            </a:r>
+          </a:p>
+        </p:txBody>
+      </p:sp>
+      <p:sp>
+        <p:nvSpPr>
+          <p:cNvPr id="40" name="Rectangle 39"/>
           <p:cNvSpPr/>
           <p:nvPr/>
         </p:nvSpPr>
@@ -5958,7 +6113,7 @@
                   <a:srgbClr val="FFFFFF"/>
                 </a:solidFill>
               </a:rPr>
-              <a:t>build_reports — Filter &amp; Ausschlüsse</a:t>
+              <a:t>build_reports — Metriken</a:t>
             </a:r>
           </a:p>
         </p:txBody>
@@ -6232,7 +6387,7 @@
                   <a:srgbClr val="2C3E50"/>
                 </a:solidFill>
               </a:rPr>
-              <a:t>Datumsfilter</a:t>
+              <a:t>Flow Time / Cycle Time</a:t>
             </a:r>
           </a:p>
         </p:txBody>
@@ -6266,7 +6421,7 @@
                   <a:srgbClr val="2C3E50"/>
                 </a:solidFill>
               </a:rPr>
-              <a:t>Von/Bis mit Kalender-Picker; "Letzte 365 Tage"-Button</a:t>
+              <a:t>Boxplot + Scatterplot; Methode A &amp; B; LOESS-Trendlinie; Perzentil-Referenzlinien; farbige Punkte; rote Ausreißer; Issue-Key als Hover-Tooltip</a:t>
             </a:r>
           </a:p>
         </p:txBody>
@@ -6386,7 +6541,7 @@
                   <a:srgbClr val="2C3E50"/>
                 </a:solidFill>
               </a:rPr>
-              <a:t>Projektfilter</a:t>
+              <a:t>Flow Velocity / Throughput</a:t>
             </a:r>
           </a:p>
         </p:txBody>
@@ -6420,7 +6575,7 @@
                   <a:srgbClr val="2C3E50"/>
                 </a:solidFill>
               </a:rPr>
-              <a:t>Auswahl aus allen in IssueTimes vorhandenen Projekten</a:t>
+              <a:t>Tagesfrequenz-Histogramm + Wochenverlauf-Linienchart + PI-Balkendiagramm; konfigurierbares Target CT</a:t>
             </a:r>
           </a:p>
         </p:txBody>
@@ -6540,7 +6695,7 @@
                   <a:srgbClr val="2C3E50"/>
                 </a:solidFill>
               </a:rPr>
-              <a:t>Issuetype-Filter</a:t>
+              <a:t>Flow Load / WIP</a:t>
             </a:r>
           </a:p>
         </p:txBody>
@@ -6574,7 +6729,7 @@
                   <a:srgbClr val="2C3E50"/>
                 </a:solidFill>
               </a:rPr>
-              <a:t>Auswahl aus allen vorhandenen Issue-Typen</a:t>
+              <a:t>Aging-WIP-Boxplot pro Stage; Issue-Anzahl je Stage als Annotation; Referenzlinien (Median, P85, Target CT); Legende</a:t>
             </a:r>
           </a:p>
         </p:txBody>
@@ -6694,7 +6849,7 @@
                   <a:srgbClr val="2C3E50"/>
                 </a:solidFill>
               </a:rPr>
-              <a:t>Ausschluss Status / Resolution</a:t>
+              <a:t>CFD</a:t>
             </a:r>
           </a:p>
         </p:txBody>
@@ -6728,7 +6883,7 @@
                   <a:srgbClr val="2C3E50"/>
                 </a:solidFill>
               </a:rPr>
-              <a:t>Issues komplett aus allen Metriken entfernen</a:t>
+              <a:t>Gestapeltes Flächendiagramm; Trendlinien an visuellen Oberkanten der &lt;First&gt;- und &lt;Closed&gt;-Stages; Monats-/KW-Achse ohne Überlappung; In/Out-Ratio im Titel</a:t>
             </a:r>
           </a:p>
         </p:txBody>
@@ -6848,7 +7003,7 @@
                   <a:srgbClr val="2C3E50"/>
                 </a:solidFill>
               </a:rPr>
-              <a:t>Zero-Day-Filter</a:t>
+              <a:t>Flow Distribution</a:t>
             </a:r>
           </a:p>
         </p:txBody>
@@ -6882,7 +7037,7 @@
                   <a:srgbClr val="2C3E50"/>
                 </a:solidFill>
               </a:rPr>
-              <a:t>Konfigurierbarer Schwellwert (Standard 5 min); ausgeschlossene Issues in separater Excel dokumentiert</a:t>
+              <a:t>Drei Teildiagramme: Issue-Typ-Donut, Stage-Prominence-Donut, Ø Cycle Time je Typ als Balken</a:t>
             </a:r>
           </a:p>
         </p:txBody>
@@ -6890,160 +7045,6 @@
       <p:sp>
         <p:nvSpPr>
           <p:cNvPr id="28" name="Rectangle 27"/>
-          <p:cNvSpPr/>
-          <p:nvPr/>
-        </p:nvSpPr>
-        <p:spPr>
-          <a:xfrm>
-            <a:off x="274320" y="4617719"/>
-            <a:ext cx="2926080" cy="658368"/>
-          </a:xfrm>
-          <a:prstGeom prst="rect">
-            <a:avLst/>
-          </a:prstGeom>
-          <a:solidFill>
-            <a:srgbClr val="FFFFFF"/>
-          </a:solidFill>
-          <a:ln>
-            <a:noFill/>
-          </a:ln>
-        </p:spPr>
-        <p:style>
-          <a:lnRef idx="1">
-            <a:schemeClr val="accent1"/>
-          </a:lnRef>
-          <a:fillRef idx="3">
-            <a:schemeClr val="accent1"/>
-          </a:fillRef>
-          <a:effectRef idx="2">
-            <a:schemeClr val="accent1"/>
-          </a:effectRef>
-          <a:fontRef idx="minor">
-            <a:schemeClr val="lt1"/>
-          </a:fontRef>
-        </p:style>
-        <p:txBody>
-          <a:bodyPr rtlCol="0" anchor="ctr"/>
-          <a:lstStyle/>
-          <a:p>
-            <a:pPr algn="ctr"/>
-          </a:p>
-        </p:txBody>
-      </p:sp>
-      <p:sp>
-        <p:nvSpPr>
-          <p:cNvPr id="29" name="Rectangle 28"/>
-          <p:cNvSpPr/>
-          <p:nvPr/>
-        </p:nvSpPr>
-        <p:spPr>
-          <a:xfrm>
-            <a:off x="3291840" y="4617719"/>
-            <a:ext cx="8595360" cy="658368"/>
-          </a:xfrm>
-          <a:prstGeom prst="rect">
-            <a:avLst/>
-          </a:prstGeom>
-          <a:solidFill>
-            <a:srgbClr val="FFFFFF"/>
-          </a:solidFill>
-          <a:ln>
-            <a:noFill/>
-          </a:ln>
-        </p:spPr>
-        <p:style>
-          <a:lnRef idx="1">
-            <a:schemeClr val="accent1"/>
-          </a:lnRef>
-          <a:fillRef idx="3">
-            <a:schemeClr val="accent1"/>
-          </a:fillRef>
-          <a:effectRef idx="2">
-            <a:schemeClr val="accent1"/>
-          </a:effectRef>
-          <a:fontRef idx="minor">
-            <a:schemeClr val="lt1"/>
-          </a:fontRef>
-        </p:style>
-        <p:txBody>
-          <a:bodyPr rtlCol="0" anchor="ctr"/>
-          <a:lstStyle/>
-          <a:p>
-            <a:pPr algn="ctr"/>
-          </a:p>
-        </p:txBody>
-      </p:sp>
-      <p:sp>
-        <p:nvSpPr>
-          <p:cNvPr id="30" name="TextBox 29"/>
-          <p:cNvSpPr txBox="1"/>
-          <p:nvPr/>
-        </p:nvSpPr>
-        <p:spPr>
-          <a:xfrm>
-            <a:off x="347472" y="4654295"/>
-            <a:ext cx="2788920" cy="603503"/>
-          </a:xfrm>
-          <a:prstGeom prst="rect">
-            <a:avLst/>
-          </a:prstGeom>
-          <a:noFill/>
-        </p:spPr>
-        <p:txBody>
-          <a:bodyPr wrap="square">
-            <a:spAutoFit/>
-          </a:bodyPr>
-          <a:lstStyle/>
-          <a:p>
-            <a:pPr algn="l"/>
-            <a:r>
-              <a:rPr sz="900" b="1">
-                <a:solidFill>
-                  <a:srgbClr val="2C3E50"/>
-                </a:solidFill>
-              </a:rPr>
-              <a:t>Datumsfilter-Bugfix</a:t>
-            </a:r>
-          </a:p>
-        </p:txBody>
-      </p:sp>
-      <p:sp>
-        <p:nvSpPr>
-          <p:cNvPr id="31" name="TextBox 30"/>
-          <p:cNvSpPr txBox="1"/>
-          <p:nvPr/>
-        </p:nvSpPr>
-        <p:spPr>
-          <a:xfrm>
-            <a:off x="3364992" y="4654295"/>
-            <a:ext cx="8412480" cy="603503"/>
-          </a:xfrm>
-          <a:prstGeom prst="rect">
-            <a:avLst/>
-          </a:prstGeom>
-          <a:noFill/>
-        </p:spPr>
-        <p:txBody>
-          <a:bodyPr wrap="square">
-            <a:spAutoFit/>
-          </a:bodyPr>
-          <a:lstStyle/>
-          <a:p>
-            <a:pPr algn="l"/>
-            <a:r>
-              <a:rPr sz="900" b="0">
-                <a:solidFill>
-                  <a:srgbClr val="2C3E50"/>
-                </a:solidFill>
-              </a:rPr>
-              <a:t>Offene Issues (kein Closed Date) wurden fälschlich vom Datumsfilter ausgeschlossen — behoben</a:t>
-            </a:r>
-          </a:p>
-        </p:txBody>
-      </p:sp>
-      <p:sp>
-        <p:nvSpPr>
-          <p:cNvPr id="32" name="Rectangle 31"/>
           <p:cNvSpPr/>
           <p:nvPr/>
         </p:nvSpPr>
@@ -7174,7 +7175,7 @@
                   <a:srgbClr val="FFFFFF"/>
                 </a:solidFill>
               </a:rPr>
-              <a:t>build_reports — Export &amp; Reporting</a:t>
+              <a:t>build_reports — Filter &amp; Ausschlüsse</a:t>
             </a:r>
           </a:p>
         </p:txBody>
@@ -7448,7 +7449,7 @@
                   <a:srgbClr val="2C3E50"/>
                 </a:solidFill>
               </a:rPr>
-              <a:t>Browser-Anzeige</a:t>
+              <a:t>Datumsfilter</a:t>
             </a:r>
           </a:p>
         </p:txBody>
@@ -7482,7 +7483,7 @@
                   <a:srgbClr val="2C3E50"/>
                 </a:solidFill>
               </a:rPr>
-              <a:t>Vollständig interaktive Plotly-Diagramme im Browser</a:t>
+              <a:t>Von/Bis mit Kalender-Picker; "Letzte 365 Tage"-Button</a:t>
             </a:r>
           </a:p>
         </p:txBody>
@@ -7602,7 +7603,7 @@
                   <a:srgbClr val="2C3E50"/>
                 </a:solidFill>
               </a:rPr>
-              <a:t>PDF-Export</a:t>
+              <a:t>Projektfilter</a:t>
             </a:r>
           </a:p>
         </p:txBody>
@@ -7636,7 +7637,7 @@
                   <a:srgbClr val="2C3E50"/>
                 </a:solidFill>
               </a:rPr>
-              <a:t>Mehrseitige PDF mit allen gewählten Metriken</a:t>
+              <a:t>Auswahl aus allen in IssueTimes vorhandenen Projekten</a:t>
             </a:r>
           </a:p>
         </p:txBody>
@@ -7756,7 +7757,7 @@
                   <a:srgbClr val="2C3E50"/>
                 </a:solidFill>
               </a:rPr>
-              <a:t>Report-Excel</a:t>
+              <a:t>Issuetype-Filter</a:t>
             </a:r>
           </a:p>
         </p:txBody>
@@ -7790,7 +7791,7 @@
                   <a:srgbClr val="2C3E50"/>
                 </a:solidFill>
               </a:rPr>
-              <a:t>Wird automatisch beim PDF-Export erzeugt; enthält gefilterte Issues mit Status Group, CT Methode A und B</a:t>
+              <a:t>Auswahl aus allen vorhandenen Issue-Typen</a:t>
             </a:r>
           </a:p>
         </p:txBody>
@@ -7910,7 +7911,7 @@
                   <a:srgbClr val="2C3E50"/>
                 </a:solidFill>
               </a:rPr>
-              <a:t>PI-Konfiguration</a:t>
+              <a:t>Ausschluss Status / Resolution</a:t>
             </a:r>
           </a:p>
         </p:txBody>
@@ -7944,7 +7945,7 @@
                   <a:srgbClr val="2C3E50"/>
                 </a:solidFill>
               </a:rPr>
-              <a:t>Eigene PI-Intervalle per JSON-Datei; ohne Datei werden Kalenderquartale verwendet</a:t>
+              <a:t>Issues komplett aus allen Metriken entfernen</a:t>
             </a:r>
           </a:p>
         </p:txBody>
@@ -7952,6 +7953,314 @@
       <p:sp>
         <p:nvSpPr>
           <p:cNvPr id="24" name="Rectangle 23"/>
+          <p:cNvSpPr/>
+          <p:nvPr/>
+        </p:nvSpPr>
+        <p:spPr>
+          <a:xfrm>
+            <a:off x="274320" y="3959351"/>
+            <a:ext cx="2926080" cy="658368"/>
+          </a:xfrm>
+          <a:prstGeom prst="rect">
+            <a:avLst/>
+          </a:prstGeom>
+          <a:solidFill>
+            <a:srgbClr val="ECF0F1"/>
+          </a:solidFill>
+          <a:ln>
+            <a:noFill/>
+          </a:ln>
+        </p:spPr>
+        <p:style>
+          <a:lnRef idx="1">
+            <a:schemeClr val="accent1"/>
+          </a:lnRef>
+          <a:fillRef idx="3">
+            <a:schemeClr val="accent1"/>
+          </a:fillRef>
+          <a:effectRef idx="2">
+            <a:schemeClr val="accent1"/>
+          </a:effectRef>
+          <a:fontRef idx="minor">
+            <a:schemeClr val="lt1"/>
+          </a:fontRef>
+        </p:style>
+        <p:txBody>
+          <a:bodyPr rtlCol="0" anchor="ctr"/>
+          <a:lstStyle/>
+          <a:p>
+            <a:pPr algn="ctr"/>
+          </a:p>
+        </p:txBody>
+      </p:sp>
+      <p:sp>
+        <p:nvSpPr>
+          <p:cNvPr id="25" name="Rectangle 24"/>
+          <p:cNvSpPr/>
+          <p:nvPr/>
+        </p:nvSpPr>
+        <p:spPr>
+          <a:xfrm>
+            <a:off x="3291840" y="3959351"/>
+            <a:ext cx="8595360" cy="658368"/>
+          </a:xfrm>
+          <a:prstGeom prst="rect">
+            <a:avLst/>
+          </a:prstGeom>
+          <a:solidFill>
+            <a:srgbClr val="ECF0F1"/>
+          </a:solidFill>
+          <a:ln>
+            <a:noFill/>
+          </a:ln>
+        </p:spPr>
+        <p:style>
+          <a:lnRef idx="1">
+            <a:schemeClr val="accent1"/>
+          </a:lnRef>
+          <a:fillRef idx="3">
+            <a:schemeClr val="accent1"/>
+          </a:fillRef>
+          <a:effectRef idx="2">
+            <a:schemeClr val="accent1"/>
+          </a:effectRef>
+          <a:fontRef idx="minor">
+            <a:schemeClr val="lt1"/>
+          </a:fontRef>
+        </p:style>
+        <p:txBody>
+          <a:bodyPr rtlCol="0" anchor="ctr"/>
+          <a:lstStyle/>
+          <a:p>
+            <a:pPr algn="ctr"/>
+          </a:p>
+        </p:txBody>
+      </p:sp>
+      <p:sp>
+        <p:nvSpPr>
+          <p:cNvPr id="26" name="TextBox 25"/>
+          <p:cNvSpPr txBox="1"/>
+          <p:nvPr/>
+        </p:nvSpPr>
+        <p:spPr>
+          <a:xfrm>
+            <a:off x="347472" y="3995927"/>
+            <a:ext cx="2788920" cy="603503"/>
+          </a:xfrm>
+          <a:prstGeom prst="rect">
+            <a:avLst/>
+          </a:prstGeom>
+          <a:noFill/>
+        </p:spPr>
+        <p:txBody>
+          <a:bodyPr wrap="square">
+            <a:spAutoFit/>
+          </a:bodyPr>
+          <a:lstStyle/>
+          <a:p>
+            <a:pPr algn="l"/>
+            <a:r>
+              <a:rPr sz="900" b="1">
+                <a:solidFill>
+                  <a:srgbClr val="2C3E50"/>
+                </a:solidFill>
+              </a:rPr>
+              <a:t>Zero-Day-Filter</a:t>
+            </a:r>
+          </a:p>
+        </p:txBody>
+      </p:sp>
+      <p:sp>
+        <p:nvSpPr>
+          <p:cNvPr id="27" name="TextBox 26"/>
+          <p:cNvSpPr txBox="1"/>
+          <p:nvPr/>
+        </p:nvSpPr>
+        <p:spPr>
+          <a:xfrm>
+            <a:off x="3364992" y="3995927"/>
+            <a:ext cx="8412480" cy="603503"/>
+          </a:xfrm>
+          <a:prstGeom prst="rect">
+            <a:avLst/>
+          </a:prstGeom>
+          <a:noFill/>
+        </p:spPr>
+        <p:txBody>
+          <a:bodyPr wrap="square">
+            <a:spAutoFit/>
+          </a:bodyPr>
+          <a:lstStyle/>
+          <a:p>
+            <a:pPr algn="l"/>
+            <a:r>
+              <a:rPr sz="900" b="0">
+                <a:solidFill>
+                  <a:srgbClr val="2C3E50"/>
+                </a:solidFill>
+              </a:rPr>
+              <a:t>Konfigurierbarer Schwellwert (Standard 5 min); ausgeschlossene Issues in separater Excel dokumentiert</a:t>
+            </a:r>
+          </a:p>
+        </p:txBody>
+      </p:sp>
+      <p:sp>
+        <p:nvSpPr>
+          <p:cNvPr id="28" name="Rectangle 27"/>
+          <p:cNvSpPr/>
+          <p:nvPr/>
+        </p:nvSpPr>
+        <p:spPr>
+          <a:xfrm>
+            <a:off x="274320" y="4617719"/>
+            <a:ext cx="2926080" cy="658368"/>
+          </a:xfrm>
+          <a:prstGeom prst="rect">
+            <a:avLst/>
+          </a:prstGeom>
+          <a:solidFill>
+            <a:srgbClr val="FFFFFF"/>
+          </a:solidFill>
+          <a:ln>
+            <a:noFill/>
+          </a:ln>
+        </p:spPr>
+        <p:style>
+          <a:lnRef idx="1">
+            <a:schemeClr val="accent1"/>
+          </a:lnRef>
+          <a:fillRef idx="3">
+            <a:schemeClr val="accent1"/>
+          </a:fillRef>
+          <a:effectRef idx="2">
+            <a:schemeClr val="accent1"/>
+          </a:effectRef>
+          <a:fontRef idx="minor">
+            <a:schemeClr val="lt1"/>
+          </a:fontRef>
+        </p:style>
+        <p:txBody>
+          <a:bodyPr rtlCol="0" anchor="ctr"/>
+          <a:lstStyle/>
+          <a:p>
+            <a:pPr algn="ctr"/>
+          </a:p>
+        </p:txBody>
+      </p:sp>
+      <p:sp>
+        <p:nvSpPr>
+          <p:cNvPr id="29" name="Rectangle 28"/>
+          <p:cNvSpPr/>
+          <p:nvPr/>
+        </p:nvSpPr>
+        <p:spPr>
+          <a:xfrm>
+            <a:off x="3291840" y="4617719"/>
+            <a:ext cx="8595360" cy="658368"/>
+          </a:xfrm>
+          <a:prstGeom prst="rect">
+            <a:avLst/>
+          </a:prstGeom>
+          <a:solidFill>
+            <a:srgbClr val="FFFFFF"/>
+          </a:solidFill>
+          <a:ln>
+            <a:noFill/>
+          </a:ln>
+        </p:spPr>
+        <p:style>
+          <a:lnRef idx="1">
+            <a:schemeClr val="accent1"/>
+          </a:lnRef>
+          <a:fillRef idx="3">
+            <a:schemeClr val="accent1"/>
+          </a:fillRef>
+          <a:effectRef idx="2">
+            <a:schemeClr val="accent1"/>
+          </a:effectRef>
+          <a:fontRef idx="minor">
+            <a:schemeClr val="lt1"/>
+          </a:fontRef>
+        </p:style>
+        <p:txBody>
+          <a:bodyPr rtlCol="0" anchor="ctr"/>
+          <a:lstStyle/>
+          <a:p>
+            <a:pPr algn="ctr"/>
+          </a:p>
+        </p:txBody>
+      </p:sp>
+      <p:sp>
+        <p:nvSpPr>
+          <p:cNvPr id="30" name="TextBox 29"/>
+          <p:cNvSpPr txBox="1"/>
+          <p:nvPr/>
+        </p:nvSpPr>
+        <p:spPr>
+          <a:xfrm>
+            <a:off x="347472" y="4654295"/>
+            <a:ext cx="2788920" cy="603503"/>
+          </a:xfrm>
+          <a:prstGeom prst="rect">
+            <a:avLst/>
+          </a:prstGeom>
+          <a:noFill/>
+        </p:spPr>
+        <p:txBody>
+          <a:bodyPr wrap="square">
+            <a:spAutoFit/>
+          </a:bodyPr>
+          <a:lstStyle/>
+          <a:p>
+            <a:pPr algn="l"/>
+            <a:r>
+              <a:rPr sz="900" b="1">
+                <a:solidFill>
+                  <a:srgbClr val="2C3E50"/>
+                </a:solidFill>
+              </a:rPr>
+              <a:t>Datumsfilter-Bugfix</a:t>
+            </a:r>
+          </a:p>
+        </p:txBody>
+      </p:sp>
+      <p:sp>
+        <p:nvSpPr>
+          <p:cNvPr id="31" name="TextBox 30"/>
+          <p:cNvSpPr txBox="1"/>
+          <p:nvPr/>
+        </p:nvSpPr>
+        <p:spPr>
+          <a:xfrm>
+            <a:off x="3364992" y="4654295"/>
+            <a:ext cx="8412480" cy="603503"/>
+          </a:xfrm>
+          <a:prstGeom prst="rect">
+            <a:avLst/>
+          </a:prstGeom>
+          <a:noFill/>
+        </p:spPr>
+        <p:txBody>
+          <a:bodyPr wrap="square">
+            <a:spAutoFit/>
+          </a:bodyPr>
+          <a:lstStyle/>
+          <a:p>
+            <a:pPr algn="l"/>
+            <a:r>
+              <a:rPr sz="900" b="0">
+                <a:solidFill>
+                  <a:srgbClr val="2C3E50"/>
+                </a:solidFill>
+              </a:rPr>
+              <a:t>Offene Issues (kein Closed Date) wurden fälschlich vom Datumsfilter ausgeschlossen — behoben</a:t>
+            </a:r>
+          </a:p>
+        </p:txBody>
+      </p:sp>
+      <p:sp>
+        <p:nvSpPr>
+          <p:cNvPr id="32" name="Rectangle 31"/>
           <p:cNvSpPr/>
           <p:nvPr/>
         </p:nvSpPr>
@@ -8082,7 +8391,7 @@
                   <a:srgbClr val="FFFFFF"/>
                 </a:solidFill>
               </a:rPr>
-              <a:t>build_reports — GUI &amp; UX</a:t>
+              <a:t>build_reports — Export &amp; Reporting</a:t>
             </a:r>
           </a:p>
         </p:txBody>
@@ -8356,7 +8665,7 @@
                   <a:srgbClr val="2C3E50"/>
                 </a:solidFill>
               </a:rPr>
-              <a:t>Terminologie</a:t>
+              <a:t>Browser-Anzeige</a:t>
             </a:r>
           </a:p>
         </p:txBody>
@@ -8390,7 +8699,7 @@
                   <a:srgbClr val="2C3E50"/>
                 </a:solidFill>
               </a:rPr>
-              <a:t>Umschaltung SAFe ↔ Global (Flow Time ↔ Cycle Time etc.)</a:t>
+              <a:t>Vollständig interaktive Plotly-Diagramme im Browser</a:t>
             </a:r>
           </a:p>
         </p:txBody>
@@ -8510,7 +8819,7 @@
                   <a:srgbClr val="2C3E50"/>
                 </a:solidFill>
               </a:rPr>
-              <a:t>Templates</a:t>
+              <a:t>PDF-Export</a:t>
             </a:r>
           </a:p>
         </p:txBody>
@@ -8544,7 +8853,7 @@
                   <a:srgbClr val="2C3E50"/>
                 </a:solidFill>
               </a:rPr>
-              <a:t>Alle Einstellungen als JSON speichern/laden; Ausschlüsse als dauerhafter Standard speicherbar</a:t>
+              <a:t>Mehrseitige PDF mit allen gewählten Metriken</a:t>
             </a:r>
           </a:p>
         </p:txBody>
@@ -8664,7 +8973,7 @@
                   <a:srgbClr val="2C3E50"/>
                 </a:solidFill>
               </a:rPr>
-              <a:t>Tooltips</a:t>
+              <a:t>Report-Excel</a:t>
             </a:r>
           </a:p>
         </p:txBody>
@@ -8698,7 +9007,7 @@
                   <a:srgbClr val="2C3E50"/>
                 </a:solidFill>
               </a:rPr>
-              <a:t>Hover-Tooltips auf allen GUI-Elementen</a:t>
+              <a:t>Wird automatisch beim PDF-Export erzeugt; enthält gefilterte Issues mit Status Group, CT Methode A und B</a:t>
             </a:r>
           </a:p>
         </p:txBody>
@@ -8818,7 +9127,7 @@
                   <a:srgbClr val="2C3E50"/>
                 </a:solidFill>
               </a:rPr>
-              <a:t>Ladebalken</a:t>
+              <a:t>PI-Konfiguration</a:t>
             </a:r>
           </a:p>
         </p:txBody>
@@ -8852,7 +9161,7 @@
                   <a:srgbClr val="2C3E50"/>
                 </a:solidFill>
               </a:rPr>
-              <a:t>Erscheint nach 3 Sekunden bei laufenden Berechnungen</a:t>
+              <a:t>Eigene PI-Intervalle per JSON-Datei; ohne Datei werden Kalenderquartale verwendet</a:t>
             </a:r>
           </a:p>
         </p:txBody>
@@ -8860,468 +9169,6 @@
       <p:sp>
         <p:nvSpPr>
           <p:cNvPr id="24" name="Rectangle 23"/>
-          <p:cNvSpPr/>
-          <p:nvPr/>
-        </p:nvSpPr>
-        <p:spPr>
-          <a:xfrm>
-            <a:off x="274320" y="3959351"/>
-            <a:ext cx="2926080" cy="658368"/>
-          </a:xfrm>
-          <a:prstGeom prst="rect">
-            <a:avLst/>
-          </a:prstGeom>
-          <a:solidFill>
-            <a:srgbClr val="ECF0F1"/>
-          </a:solidFill>
-          <a:ln>
-            <a:noFill/>
-          </a:ln>
-        </p:spPr>
-        <p:style>
-          <a:lnRef idx="1">
-            <a:schemeClr val="accent1"/>
-          </a:lnRef>
-          <a:fillRef idx="3">
-            <a:schemeClr val="accent1"/>
-          </a:fillRef>
-          <a:effectRef idx="2">
-            <a:schemeClr val="accent1"/>
-          </a:effectRef>
-          <a:fontRef idx="minor">
-            <a:schemeClr val="lt1"/>
-          </a:fontRef>
-        </p:style>
-        <p:txBody>
-          <a:bodyPr rtlCol="0" anchor="ctr"/>
-          <a:lstStyle/>
-          <a:p>
-            <a:pPr algn="ctr"/>
-          </a:p>
-        </p:txBody>
-      </p:sp>
-      <p:sp>
-        <p:nvSpPr>
-          <p:cNvPr id="25" name="Rectangle 24"/>
-          <p:cNvSpPr/>
-          <p:nvPr/>
-        </p:nvSpPr>
-        <p:spPr>
-          <a:xfrm>
-            <a:off x="3291840" y="3959351"/>
-            <a:ext cx="8595360" cy="658368"/>
-          </a:xfrm>
-          <a:prstGeom prst="rect">
-            <a:avLst/>
-          </a:prstGeom>
-          <a:solidFill>
-            <a:srgbClr val="ECF0F1"/>
-          </a:solidFill>
-          <a:ln>
-            <a:noFill/>
-          </a:ln>
-        </p:spPr>
-        <p:style>
-          <a:lnRef idx="1">
-            <a:schemeClr val="accent1"/>
-          </a:lnRef>
-          <a:fillRef idx="3">
-            <a:schemeClr val="accent1"/>
-          </a:fillRef>
-          <a:effectRef idx="2">
-            <a:schemeClr val="accent1"/>
-          </a:effectRef>
-          <a:fontRef idx="minor">
-            <a:schemeClr val="lt1"/>
-          </a:fontRef>
-        </p:style>
-        <p:txBody>
-          <a:bodyPr rtlCol="0" anchor="ctr"/>
-          <a:lstStyle/>
-          <a:p>
-            <a:pPr algn="ctr"/>
-          </a:p>
-        </p:txBody>
-      </p:sp>
-      <p:sp>
-        <p:nvSpPr>
-          <p:cNvPr id="26" name="TextBox 25"/>
-          <p:cNvSpPr txBox="1"/>
-          <p:nvPr/>
-        </p:nvSpPr>
-        <p:spPr>
-          <a:xfrm>
-            <a:off x="347472" y="3995927"/>
-            <a:ext cx="2788920" cy="603503"/>
-          </a:xfrm>
-          <a:prstGeom prst="rect">
-            <a:avLst/>
-          </a:prstGeom>
-          <a:noFill/>
-        </p:spPr>
-        <p:txBody>
-          <a:bodyPr wrap="square">
-            <a:spAutoFit/>
-          </a:bodyPr>
-          <a:lstStyle/>
-          <a:p>
-            <a:pPr algn="l"/>
-            <a:r>
-              <a:rPr sz="900" b="1">
-                <a:solidFill>
-                  <a:srgbClr val="2C3E50"/>
-                </a:solidFill>
-              </a:rPr>
-              <a:t>Stage-Konsistenzprüfung</a:t>
-            </a:r>
-          </a:p>
-        </p:txBody>
-      </p:sp>
-      <p:sp>
-        <p:nvSpPr>
-          <p:cNvPr id="27" name="TextBox 26"/>
-          <p:cNvSpPr txBox="1"/>
-          <p:nvPr/>
-        </p:nvSpPr>
-        <p:spPr>
-          <a:xfrm>
-            <a:off x="3364992" y="3995927"/>
-            <a:ext cx="8412480" cy="603503"/>
-          </a:xfrm>
-          <a:prstGeom prst="rect">
-            <a:avLst/>
-          </a:prstGeom>
-          <a:noFill/>
-        </p:spPr>
-        <p:txBody>
-          <a:bodyPr wrap="square">
-            <a:spAutoFit/>
-          </a:bodyPr>
-          <a:lstStyle/>
-          <a:p>
-            <a:pPr algn="l"/>
-            <a:r>
-              <a:rPr sz="900" b="0">
-                <a:solidFill>
-                  <a:srgbClr val="2C3E50"/>
-                </a:solidFill>
-              </a:rPr>
-              <a:t>Warnung wenn IssueTimes und CFD unterschiedliche Stages haben</a:t>
-            </a:r>
-          </a:p>
-        </p:txBody>
-      </p:sp>
-      <p:sp>
-        <p:nvSpPr>
-          <p:cNvPr id="28" name="Rectangle 27"/>
-          <p:cNvSpPr/>
-          <p:nvPr/>
-        </p:nvSpPr>
-        <p:spPr>
-          <a:xfrm>
-            <a:off x="274320" y="4617719"/>
-            <a:ext cx="2926080" cy="658368"/>
-          </a:xfrm>
-          <a:prstGeom prst="rect">
-            <a:avLst/>
-          </a:prstGeom>
-          <a:solidFill>
-            <a:srgbClr val="FFFFFF"/>
-          </a:solidFill>
-          <a:ln>
-            <a:noFill/>
-          </a:ln>
-        </p:spPr>
-        <p:style>
-          <a:lnRef idx="1">
-            <a:schemeClr val="accent1"/>
-          </a:lnRef>
-          <a:fillRef idx="3">
-            <a:schemeClr val="accent1"/>
-          </a:fillRef>
-          <a:effectRef idx="2">
-            <a:schemeClr val="accent1"/>
-          </a:effectRef>
-          <a:fontRef idx="minor">
-            <a:schemeClr val="lt1"/>
-          </a:fontRef>
-        </p:style>
-        <p:txBody>
-          <a:bodyPr rtlCol="0" anchor="ctr"/>
-          <a:lstStyle/>
-          <a:p>
-            <a:pPr algn="ctr"/>
-          </a:p>
-        </p:txBody>
-      </p:sp>
-      <p:sp>
-        <p:nvSpPr>
-          <p:cNvPr id="29" name="Rectangle 28"/>
-          <p:cNvSpPr/>
-          <p:nvPr/>
-        </p:nvSpPr>
-        <p:spPr>
-          <a:xfrm>
-            <a:off x="3291840" y="4617719"/>
-            <a:ext cx="8595360" cy="658368"/>
-          </a:xfrm>
-          <a:prstGeom prst="rect">
-            <a:avLst/>
-          </a:prstGeom>
-          <a:solidFill>
-            <a:srgbClr val="FFFFFF"/>
-          </a:solidFill>
-          <a:ln>
-            <a:noFill/>
-          </a:ln>
-        </p:spPr>
-        <p:style>
-          <a:lnRef idx="1">
-            <a:schemeClr val="accent1"/>
-          </a:lnRef>
-          <a:fillRef idx="3">
-            <a:schemeClr val="accent1"/>
-          </a:fillRef>
-          <a:effectRef idx="2">
-            <a:schemeClr val="accent1"/>
-          </a:effectRef>
-          <a:fontRef idx="minor">
-            <a:schemeClr val="lt1"/>
-          </a:fontRef>
-        </p:style>
-        <p:txBody>
-          <a:bodyPr rtlCol="0" anchor="ctr"/>
-          <a:lstStyle/>
-          <a:p>
-            <a:pPr algn="ctr"/>
-          </a:p>
-        </p:txBody>
-      </p:sp>
-      <p:sp>
-        <p:nvSpPr>
-          <p:cNvPr id="30" name="TextBox 29"/>
-          <p:cNvSpPr txBox="1"/>
-          <p:nvPr/>
-        </p:nvSpPr>
-        <p:spPr>
-          <a:xfrm>
-            <a:off x="347472" y="4654295"/>
-            <a:ext cx="2788920" cy="603503"/>
-          </a:xfrm>
-          <a:prstGeom prst="rect">
-            <a:avLst/>
-          </a:prstGeom>
-          <a:noFill/>
-        </p:spPr>
-        <p:txBody>
-          <a:bodyPr wrap="square">
-            <a:spAutoFit/>
-          </a:bodyPr>
-          <a:lstStyle/>
-          <a:p>
-            <a:pPr algn="l"/>
-            <a:r>
-              <a:rPr sz="900" b="1">
-                <a:solidFill>
-                  <a:srgbClr val="2C3E50"/>
-                </a:solidFill>
-              </a:rPr>
-              <a:t>Kollisionsfreie Annotations</a:t>
-            </a:r>
-          </a:p>
-        </p:txBody>
-      </p:sp>
-      <p:sp>
-        <p:nvSpPr>
-          <p:cNvPr id="31" name="TextBox 30"/>
-          <p:cNvSpPr txBox="1"/>
-          <p:nvPr/>
-        </p:nvSpPr>
-        <p:spPr>
-          <a:xfrm>
-            <a:off x="3364992" y="4654295"/>
-            <a:ext cx="8412480" cy="603503"/>
-          </a:xfrm>
-          <a:prstGeom prst="rect">
-            <a:avLst/>
-          </a:prstGeom>
-          <a:noFill/>
-        </p:spPr>
-        <p:txBody>
-          <a:bodyPr wrap="square">
-            <a:spAutoFit/>
-          </a:bodyPr>
-          <a:lstStyle/>
-          <a:p>
-            <a:pPr algn="l"/>
-            <a:r>
-              <a:rPr sz="900" b="0">
-                <a:solidFill>
-                  <a:srgbClr val="2C3E50"/>
-                </a:solidFill>
-              </a:rPr>
-              <a:t>Referenzlinien-Labels weichen automatisch aus wenn sie sich überlappen</a:t>
-            </a:r>
-          </a:p>
-        </p:txBody>
-      </p:sp>
-      <p:sp>
-        <p:nvSpPr>
-          <p:cNvPr id="32" name="Rectangle 31"/>
-          <p:cNvSpPr/>
-          <p:nvPr/>
-        </p:nvSpPr>
-        <p:spPr>
-          <a:xfrm>
-            <a:off x="274320" y="5276087"/>
-            <a:ext cx="2926080" cy="658368"/>
-          </a:xfrm>
-          <a:prstGeom prst="rect">
-            <a:avLst/>
-          </a:prstGeom>
-          <a:solidFill>
-            <a:srgbClr val="ECF0F1"/>
-          </a:solidFill>
-          <a:ln>
-            <a:noFill/>
-          </a:ln>
-        </p:spPr>
-        <p:style>
-          <a:lnRef idx="1">
-            <a:schemeClr val="accent1"/>
-          </a:lnRef>
-          <a:fillRef idx="3">
-            <a:schemeClr val="accent1"/>
-          </a:fillRef>
-          <a:effectRef idx="2">
-            <a:schemeClr val="accent1"/>
-          </a:effectRef>
-          <a:fontRef idx="minor">
-            <a:schemeClr val="lt1"/>
-          </a:fontRef>
-        </p:style>
-        <p:txBody>
-          <a:bodyPr rtlCol="0" anchor="ctr"/>
-          <a:lstStyle/>
-          <a:p>
-            <a:pPr algn="ctr"/>
-          </a:p>
-        </p:txBody>
-      </p:sp>
-      <p:sp>
-        <p:nvSpPr>
-          <p:cNvPr id="33" name="Rectangle 32"/>
-          <p:cNvSpPr/>
-          <p:nvPr/>
-        </p:nvSpPr>
-        <p:spPr>
-          <a:xfrm>
-            <a:off x="3291840" y="5276087"/>
-            <a:ext cx="8595360" cy="658368"/>
-          </a:xfrm>
-          <a:prstGeom prst="rect">
-            <a:avLst/>
-          </a:prstGeom>
-          <a:solidFill>
-            <a:srgbClr val="ECF0F1"/>
-          </a:solidFill>
-          <a:ln>
-            <a:noFill/>
-          </a:ln>
-        </p:spPr>
-        <p:style>
-          <a:lnRef idx="1">
-            <a:schemeClr val="accent1"/>
-          </a:lnRef>
-          <a:fillRef idx="3">
-            <a:schemeClr val="accent1"/>
-          </a:fillRef>
-          <a:effectRef idx="2">
-            <a:schemeClr val="accent1"/>
-          </a:effectRef>
-          <a:fontRef idx="minor">
-            <a:schemeClr val="lt1"/>
-          </a:fontRef>
-        </p:style>
-        <p:txBody>
-          <a:bodyPr rtlCol="0" anchor="ctr"/>
-          <a:lstStyle/>
-          <a:p>
-            <a:pPr algn="ctr"/>
-          </a:p>
-        </p:txBody>
-      </p:sp>
-      <p:sp>
-        <p:nvSpPr>
-          <p:cNvPr id="34" name="TextBox 33"/>
-          <p:cNvSpPr txBox="1"/>
-          <p:nvPr/>
-        </p:nvSpPr>
-        <p:spPr>
-          <a:xfrm>
-            <a:off x="347472" y="5312663"/>
-            <a:ext cx="2788920" cy="603503"/>
-          </a:xfrm>
-          <a:prstGeom prst="rect">
-            <a:avLst/>
-          </a:prstGeom>
-          <a:noFill/>
-        </p:spPr>
-        <p:txBody>
-          <a:bodyPr wrap="square">
-            <a:spAutoFit/>
-          </a:bodyPr>
-          <a:lstStyle/>
-          <a:p>
-            <a:pPr algn="l"/>
-            <a:r>
-              <a:rPr sz="900" b="1">
-                <a:solidFill>
-                  <a:srgbClr val="2C3E50"/>
-                </a:solidFill>
-              </a:rPr>
-              <a:t>Doppelklick-Starter</a:t>
-            </a:r>
-          </a:p>
-        </p:txBody>
-      </p:sp>
-      <p:sp>
-        <p:nvSpPr>
-          <p:cNvPr id="35" name="TextBox 34"/>
-          <p:cNvSpPr txBox="1"/>
-          <p:nvPr/>
-        </p:nvSpPr>
-        <p:spPr>
-          <a:xfrm>
-            <a:off x="3364992" y="5312663"/>
-            <a:ext cx="8412480" cy="603503"/>
-          </a:xfrm>
-          <a:prstGeom prst="rect">
-            <a:avLst/>
-          </a:prstGeom>
-          <a:noFill/>
-        </p:spPr>
-        <p:txBody>
-          <a:bodyPr wrap="square">
-            <a:spAutoFit/>
-          </a:bodyPr>
-          <a:lstStyle/>
-          <a:p>
-            <a:pPr algn="l"/>
-            <a:r>
-              <a:rPr sz="900" b="0">
-                <a:solidFill>
-                  <a:srgbClr val="2C3E50"/>
-                </a:solidFill>
-              </a:rPr>
-              <a:t>build_reports_gui.pyw startet die GUI ohne Konsolenfenster</a:t>
-            </a:r>
-          </a:p>
-        </p:txBody>
-      </p:sp>
-      <p:sp>
-        <p:nvSpPr>
-          <p:cNvPr id="36" name="Rectangle 35"/>
           <p:cNvSpPr/>
           <p:nvPr/>
         </p:nvSpPr>
@@ -9452,7 +9299,7 @@
                   <a:srgbClr val="FFFFFF"/>
                 </a:solidFill>
               </a:rPr>
-              <a:t>Infrastruktur &amp; Dokumentation</a:t>
+              <a:t>build_reports — GUI &amp; UX</a:t>
             </a:r>
           </a:p>
         </p:txBody>
@@ -9726,7 +9573,7 @@
                   <a:srgbClr val="2C3E50"/>
                 </a:solidFill>
               </a:rPr>
-              <a:t>Versionierung</a:t>
+              <a:t>Terminologie</a:t>
             </a:r>
           </a:p>
         </p:txBody>
@@ -9760,7 +9607,7 @@
                   <a:srgbClr val="2C3E50"/>
                 </a:solidFill>
               </a:rPr>
-              <a:t>SemVer ab v0.2.0; zentrale version.py wird von beiden GUIs und den Manuals gelesen</a:t>
+              <a:t>Umschaltung SAFe ↔ Global (Flow Time ↔ Cycle Time etc.)</a:t>
             </a:r>
           </a:p>
         </p:txBody>
@@ -9880,7 +9727,7 @@
                   <a:srgbClr val="2C3E50"/>
                 </a:solidFill>
               </a:rPr>
-              <a:t>Sprachauswahl</a:t>
+              <a:t>Templates</a:t>
             </a:r>
           </a:p>
         </p:txBody>
@@ -9914,7 +9761,7 @@
                   <a:srgbClr val="2C3E50"/>
                 </a:solidFill>
               </a:rPr>
-              <a:t>DE/EN in beiden GUIs; Flagge 🇩🇪/🇬🇧 ganz rechts im Menüband; letzte Wahl wird in ~/.situation_report/prefs.json gespeichert</a:t>
+              <a:t>Alle Einstellungen als JSON speichern/laden; Ausschlüsse als dauerhafter Standard speicherbar; Menü-Dialog zuverlässig auf allen Windows-Displays dank parent=self und Hover-Scroll-Binding</a:t>
             </a:r>
           </a:p>
         </p:txBody>
@@ -10034,7 +9881,7 @@
                   <a:srgbClr val="2C3E50"/>
                 </a:solidFill>
               </a:rPr>
-              <a:t>PDF-Manuals</a:t>
+              <a:t>Tooltips</a:t>
             </a:r>
           </a:p>
         </p:txBody>
@@ -10068,7 +9915,7 @@
                   <a:srgbClr val="2C3E50"/>
                 </a:solidFill>
               </a:rPr>
-              <a:t>Benutzerhandbuch (DE) + User Manual (EN) für build_reports und transform_data; generiert mit ReportLab inkl. echter Beispieldiagramme</a:t>
+              <a:t>Hover-Tooltips auf allen GUI-Elementen</a:t>
             </a:r>
           </a:p>
         </p:txBody>
@@ -10188,7 +10035,7 @@
                   <a:srgbClr val="2C3E50"/>
                 </a:solidFill>
               </a:rPr>
-              <a:t>Manual-Link in GUI</a:t>
+              <a:t>Ladebalken</a:t>
             </a:r>
           </a:p>
         </p:txBody>
@@ -10222,7 +10069,7 @@
                   <a:srgbClr val="2C3E50"/>
                 </a:solidFill>
               </a:rPr>
-              <a:t>Hilfe-Menü öffnet das sprachpassende PDF direkt auf GitHub Pages</a:t>
+              <a:t>Erscheint nach 3 Sekunden bei laufenden Berechnungen</a:t>
             </a:r>
           </a:p>
         </p:txBody>
@@ -10342,7 +10189,7 @@
                   <a:srgbClr val="2C3E50"/>
                 </a:solidFill>
               </a:rPr>
-              <a:t>GitHub Pages Doku</a:t>
+              <a:t>Stage-Konsistenzprüfung</a:t>
             </a:r>
           </a:p>
         </p:txBody>
@@ -10376,7 +10223,7 @@
                   <a:srgbClr val="2C3E50"/>
                 </a:solidFill>
               </a:rPr>
-              <a:t>MkDocs-Site mit DE/EN-Doku für alle Module; Architektur nach C4-Modell</a:t>
+              <a:t>Warnung wenn IssueTimes und CFD unterschiedliche Stages haben</a:t>
             </a:r>
           </a:p>
         </p:txBody>
@@ -10496,7 +10343,7 @@
                   <a:srgbClr val="2C3E50"/>
                 </a:solidFill>
               </a:rPr>
-              <a:t>CI/CD</a:t>
+              <a:t>Kollisionsfreie Annotations</a:t>
             </a:r>
           </a:p>
         </p:txBody>
@@ -10530,7 +10377,7 @@
                   <a:srgbClr val="2C3E50"/>
                 </a:solidFill>
               </a:rPr>
-              <a:t>GitHub Actions für automatisches Docs-Deployment</a:t>
+              <a:t>Referenzlinien-Labels weichen automatisch aus wenn sie sich überlappen</a:t>
             </a:r>
           </a:p>
         </p:txBody>
@@ -10650,7 +10497,7 @@
                   <a:srgbClr val="2C3E50"/>
                 </a:solidFill>
               </a:rPr>
-              <a:t>Tests</a:t>
+              <a:t>Doppelklick-Starter</a:t>
             </a:r>
           </a:p>
         </p:txBody>
@@ -10684,7 +10531,1531 @@
                   <a:srgbClr val="2C3E50"/>
                 </a:solidFill>
               </a:rPr>
-              <a:t>Unit- und Acceptance-Tests für beide Module; aktuell 448 Tests</a:t>
+              <a:t>build_reports_gui.pyw startet die GUI ohne Konsolenfenster</a:t>
+            </a:r>
+          </a:p>
+        </p:txBody>
+      </p:sp>
+      <p:sp>
+        <p:nvSpPr>
+          <p:cNvPr id="36" name="Rectangle 35"/>
+          <p:cNvSpPr/>
+          <p:nvPr/>
+        </p:nvSpPr>
+        <p:spPr>
+          <a:xfrm>
+            <a:off x="274320" y="5934455"/>
+            <a:ext cx="2926080" cy="658368"/>
+          </a:xfrm>
+          <a:prstGeom prst="rect">
+            <a:avLst/>
+          </a:prstGeom>
+          <a:solidFill>
+            <a:srgbClr val="FFFFFF"/>
+          </a:solidFill>
+          <a:ln>
+            <a:noFill/>
+          </a:ln>
+        </p:spPr>
+        <p:style>
+          <a:lnRef idx="1">
+            <a:schemeClr val="accent1"/>
+          </a:lnRef>
+          <a:fillRef idx="3">
+            <a:schemeClr val="accent1"/>
+          </a:fillRef>
+          <a:effectRef idx="2">
+            <a:schemeClr val="accent1"/>
+          </a:effectRef>
+          <a:fontRef idx="minor">
+            <a:schemeClr val="lt1"/>
+          </a:fontRef>
+        </p:style>
+        <p:txBody>
+          <a:bodyPr rtlCol="0" anchor="ctr"/>
+          <a:lstStyle/>
+          <a:p>
+            <a:pPr algn="ctr"/>
+          </a:p>
+        </p:txBody>
+      </p:sp>
+      <p:sp>
+        <p:nvSpPr>
+          <p:cNvPr id="37" name="Rectangle 36"/>
+          <p:cNvSpPr/>
+          <p:nvPr/>
+        </p:nvSpPr>
+        <p:spPr>
+          <a:xfrm>
+            <a:off x="3291840" y="5934455"/>
+            <a:ext cx="8595360" cy="658368"/>
+          </a:xfrm>
+          <a:prstGeom prst="rect">
+            <a:avLst/>
+          </a:prstGeom>
+          <a:solidFill>
+            <a:srgbClr val="FFFFFF"/>
+          </a:solidFill>
+          <a:ln>
+            <a:noFill/>
+          </a:ln>
+        </p:spPr>
+        <p:style>
+          <a:lnRef idx="1">
+            <a:schemeClr val="accent1"/>
+          </a:lnRef>
+          <a:fillRef idx="3">
+            <a:schemeClr val="accent1"/>
+          </a:fillRef>
+          <a:effectRef idx="2">
+            <a:schemeClr val="accent1"/>
+          </a:effectRef>
+          <a:fontRef idx="minor">
+            <a:schemeClr val="lt1"/>
+          </a:fontRef>
+        </p:style>
+        <p:txBody>
+          <a:bodyPr rtlCol="0" anchor="ctr"/>
+          <a:lstStyle/>
+          <a:p>
+            <a:pPr algn="ctr"/>
+          </a:p>
+        </p:txBody>
+      </p:sp>
+      <p:sp>
+        <p:nvSpPr>
+          <p:cNvPr id="38" name="TextBox 37"/>
+          <p:cNvSpPr txBox="1"/>
+          <p:nvPr/>
+        </p:nvSpPr>
+        <p:spPr>
+          <a:xfrm>
+            <a:off x="347472" y="5971031"/>
+            <a:ext cx="2788920" cy="603503"/>
+          </a:xfrm>
+          <a:prstGeom prst="rect">
+            <a:avLst/>
+          </a:prstGeom>
+          <a:noFill/>
+        </p:spPr>
+        <p:txBody>
+          <a:bodyPr wrap="square">
+            <a:spAutoFit/>
+          </a:bodyPr>
+          <a:lstStyle/>
+          <a:p>
+            <a:pPr algn="l"/>
+            <a:r>
+              <a:rPr sz="900" b="1">
+                <a:solidFill>
+                  <a:srgbClr val="2C3E50"/>
+                </a:solidFill>
+              </a:rPr>
+              <a:t>Scrollbare Form</a:t>
+            </a:r>
+          </a:p>
+        </p:txBody>
+      </p:sp>
+      <p:sp>
+        <p:nvSpPr>
+          <p:cNvPr id="39" name="TextBox 38"/>
+          <p:cNvSpPr txBox="1"/>
+          <p:nvPr/>
+        </p:nvSpPr>
+        <p:spPr>
+          <a:xfrm>
+            <a:off x="3364992" y="5971031"/>
+            <a:ext cx="8412480" cy="603503"/>
+          </a:xfrm>
+          <a:prstGeom prst="rect">
+            <a:avLst/>
+          </a:prstGeom>
+          <a:noFill/>
+        </p:spPr>
+        <p:txBody>
+          <a:bodyPr wrap="square">
+            <a:spAutoFit/>
+          </a:bodyPr>
+          <a:lstStyle/>
+          <a:p>
+            <a:pPr algn="l"/>
+            <a:r>
+              <a:rPr sz="900" b="0">
+                <a:solidFill>
+                  <a:srgbClr val="2C3E50"/>
+                </a:solidFill>
+              </a:rPr>
+              <a:t>Formbereich in Canvas gewrappt — vollständig scrollbar auf FullHD-Displays (1080p); Log-Bereich fest am unteren Rand</a:t>
+            </a:r>
+          </a:p>
+        </p:txBody>
+      </p:sp>
+      <p:sp>
+        <p:nvSpPr>
+          <p:cNvPr id="40" name="Rectangle 39"/>
+          <p:cNvSpPr/>
+          <p:nvPr/>
+        </p:nvSpPr>
+        <p:spPr>
+          <a:xfrm>
+            <a:off x="0" y="6720840"/>
+            <a:ext cx="12188952" cy="137160"/>
+          </a:xfrm>
+          <a:prstGeom prst="rect">
+            <a:avLst/>
+          </a:prstGeom>
+          <a:solidFill>
+            <a:srgbClr val="2980B9"/>
+          </a:solidFill>
+          <a:ln>
+            <a:noFill/>
+          </a:ln>
+        </p:spPr>
+        <p:style>
+          <a:lnRef idx="1">
+            <a:schemeClr val="accent1"/>
+          </a:lnRef>
+          <a:fillRef idx="3">
+            <a:schemeClr val="accent1"/>
+          </a:fillRef>
+          <a:effectRef idx="2">
+            <a:schemeClr val="accent1"/>
+          </a:effectRef>
+          <a:fontRef idx="minor">
+            <a:schemeClr val="lt1"/>
+          </a:fontRef>
+        </p:style>
+        <p:txBody>
+          <a:bodyPr rtlCol="0" anchor="ctr"/>
+          <a:lstStyle/>
+          <a:p>
+            <a:pPr algn="ctr"/>
+          </a:p>
+        </p:txBody>
+      </p:sp>
+    </p:spTree>
+  </p:cSld>
+  <p:clrMapOvr>
+    <a:masterClrMapping/>
+  </p:clrMapOvr>
+</p:sld>
+</file>
+
+<file path=ppt/slides/slide8.xml><?xml version="1.0" encoding="utf-8"?>
+<p:sld xmlns:a="http://schemas.openxmlformats.org/drawingml/2006/main" xmlns:p="http://schemas.openxmlformats.org/presentationml/2006/main" xmlns:r="http://schemas.openxmlformats.org/officeDocument/2006/relationships">
+  <p:cSld>
+    <p:spTree>
+      <p:nvGrpSpPr>
+        <p:cNvPr id="1" name=""/>
+        <p:cNvGrpSpPr/>
+        <p:nvPr/>
+      </p:nvGrpSpPr>
+      <p:grpSpPr/>
+      <p:sp>
+        <p:nvSpPr>
+          <p:cNvPr id="2" name="Rectangle 1"/>
+          <p:cNvSpPr/>
+          <p:nvPr/>
+        </p:nvSpPr>
+        <p:spPr>
+          <a:xfrm>
+            <a:off x="0" y="0"/>
+            <a:ext cx="12188952" cy="822960"/>
+          </a:xfrm>
+          <a:prstGeom prst="rect">
+            <a:avLst/>
+          </a:prstGeom>
+          <a:solidFill>
+            <a:srgbClr val="2C3E50"/>
+          </a:solidFill>
+          <a:ln>
+            <a:noFill/>
+          </a:ln>
+        </p:spPr>
+        <p:style>
+          <a:lnRef idx="1">
+            <a:schemeClr val="accent1"/>
+          </a:lnRef>
+          <a:fillRef idx="3">
+            <a:schemeClr val="accent1"/>
+          </a:fillRef>
+          <a:effectRef idx="2">
+            <a:schemeClr val="accent1"/>
+          </a:effectRef>
+          <a:fontRef idx="minor">
+            <a:schemeClr val="lt1"/>
+          </a:fontRef>
+        </p:style>
+        <p:txBody>
+          <a:bodyPr rtlCol="0" anchor="ctr"/>
+          <a:lstStyle/>
+          <a:p>
+            <a:pPr algn="ctr"/>
+          </a:p>
+        </p:txBody>
+      </p:sp>
+      <p:sp>
+        <p:nvSpPr>
+          <p:cNvPr id="3" name="TextBox 2"/>
+          <p:cNvSpPr txBox="1"/>
+          <p:nvPr/>
+        </p:nvSpPr>
+        <p:spPr>
+          <a:xfrm>
+            <a:off x="274320" y="91440"/>
+            <a:ext cx="11612880" cy="640080"/>
+          </a:xfrm>
+          <a:prstGeom prst="rect">
+            <a:avLst/>
+          </a:prstGeom>
+          <a:noFill/>
+        </p:spPr>
+        <p:txBody>
+          <a:bodyPr wrap="square">
+            <a:spAutoFit/>
+          </a:bodyPr>
+          <a:lstStyle/>
+          <a:p>
+            <a:pPr algn="l"/>
+            <a:r>
+              <a:rPr sz="2200" b="1">
+                <a:solidFill>
+                  <a:srgbClr val="FFFFFF"/>
+                </a:solidFill>
+              </a:rPr>
+              <a:t>Infrastruktur &amp; Dokumentation</a:t>
+            </a:r>
+          </a:p>
+        </p:txBody>
+      </p:sp>
+      <p:sp>
+        <p:nvSpPr>
+          <p:cNvPr id="4" name="Rectangle 3"/>
+          <p:cNvSpPr/>
+          <p:nvPr/>
+        </p:nvSpPr>
+        <p:spPr>
+          <a:xfrm>
+            <a:off x="274320" y="914400"/>
+            <a:ext cx="2926080" cy="320040"/>
+          </a:xfrm>
+          <a:prstGeom prst="rect">
+            <a:avLst/>
+          </a:prstGeom>
+          <a:solidFill>
+            <a:srgbClr val="2980B9"/>
+          </a:solidFill>
+          <a:ln>
+            <a:noFill/>
+          </a:ln>
+        </p:spPr>
+        <p:style>
+          <a:lnRef idx="1">
+            <a:schemeClr val="accent1"/>
+          </a:lnRef>
+          <a:fillRef idx="3">
+            <a:schemeClr val="accent1"/>
+          </a:fillRef>
+          <a:effectRef idx="2">
+            <a:schemeClr val="accent1"/>
+          </a:effectRef>
+          <a:fontRef idx="minor">
+            <a:schemeClr val="lt1"/>
+          </a:fontRef>
+        </p:style>
+        <p:txBody>
+          <a:bodyPr rtlCol="0" anchor="ctr"/>
+          <a:lstStyle/>
+          <a:p>
+            <a:pPr algn="ctr"/>
+          </a:p>
+        </p:txBody>
+      </p:sp>
+      <p:sp>
+        <p:nvSpPr>
+          <p:cNvPr id="5" name="Rectangle 4"/>
+          <p:cNvSpPr/>
+          <p:nvPr/>
+        </p:nvSpPr>
+        <p:spPr>
+          <a:xfrm>
+            <a:off x="3291840" y="914400"/>
+            <a:ext cx="8595360" cy="320040"/>
+          </a:xfrm>
+          <a:prstGeom prst="rect">
+            <a:avLst/>
+          </a:prstGeom>
+          <a:solidFill>
+            <a:srgbClr val="2980B9"/>
+          </a:solidFill>
+          <a:ln>
+            <a:noFill/>
+          </a:ln>
+        </p:spPr>
+        <p:style>
+          <a:lnRef idx="1">
+            <a:schemeClr val="accent1"/>
+          </a:lnRef>
+          <a:fillRef idx="3">
+            <a:schemeClr val="accent1"/>
+          </a:fillRef>
+          <a:effectRef idx="2">
+            <a:schemeClr val="accent1"/>
+          </a:effectRef>
+          <a:fontRef idx="minor">
+            <a:schemeClr val="lt1"/>
+          </a:fontRef>
+        </p:style>
+        <p:txBody>
+          <a:bodyPr rtlCol="0" anchor="ctr"/>
+          <a:lstStyle/>
+          <a:p>
+            <a:pPr algn="ctr"/>
+          </a:p>
+        </p:txBody>
+      </p:sp>
+      <p:sp>
+        <p:nvSpPr>
+          <p:cNvPr id="6" name="TextBox 5"/>
+          <p:cNvSpPr txBox="1"/>
+          <p:nvPr/>
+        </p:nvSpPr>
+        <p:spPr>
+          <a:xfrm>
+            <a:off x="320040" y="932688"/>
+            <a:ext cx="2834640" cy="274320"/>
+          </a:xfrm>
+          <a:prstGeom prst="rect">
+            <a:avLst/>
+          </a:prstGeom>
+          <a:noFill/>
+        </p:spPr>
+        <p:txBody>
+          <a:bodyPr wrap="square">
+            <a:spAutoFit/>
+          </a:bodyPr>
+          <a:lstStyle/>
+          <a:p>
+            <a:pPr algn="l"/>
+            <a:r>
+              <a:rPr sz="900" b="1">
+                <a:solidFill>
+                  <a:srgbClr val="FFFFFF"/>
+                </a:solidFill>
+              </a:rPr>
+              <a:t>Feature</a:t>
+            </a:r>
+          </a:p>
+        </p:txBody>
+      </p:sp>
+      <p:sp>
+        <p:nvSpPr>
+          <p:cNvPr id="7" name="TextBox 6"/>
+          <p:cNvSpPr txBox="1"/>
+          <p:nvPr/>
+        </p:nvSpPr>
+        <p:spPr>
+          <a:xfrm>
+            <a:off x="3337560" y="932688"/>
+            <a:ext cx="8503920" cy="274320"/>
+          </a:xfrm>
+          <a:prstGeom prst="rect">
+            <a:avLst/>
+          </a:prstGeom>
+          <a:noFill/>
+        </p:spPr>
+        <p:txBody>
+          <a:bodyPr wrap="square">
+            <a:spAutoFit/>
+          </a:bodyPr>
+          <a:lstStyle/>
+          <a:p>
+            <a:pPr algn="l"/>
+            <a:r>
+              <a:rPr sz="900" b="1">
+                <a:solidFill>
+                  <a:srgbClr val="FFFFFF"/>
+                </a:solidFill>
+              </a:rPr>
+              <a:t>Beschreibung</a:t>
+            </a:r>
+          </a:p>
+        </p:txBody>
+      </p:sp>
+      <p:sp>
+        <p:nvSpPr>
+          <p:cNvPr id="8" name="Rectangle 7"/>
+          <p:cNvSpPr/>
+          <p:nvPr/>
+        </p:nvSpPr>
+        <p:spPr>
+          <a:xfrm>
+            <a:off x="274320" y="1325880"/>
+            <a:ext cx="2926080" cy="658368"/>
+          </a:xfrm>
+          <a:prstGeom prst="rect">
+            <a:avLst/>
+          </a:prstGeom>
+          <a:solidFill>
+            <a:srgbClr val="ECF0F1"/>
+          </a:solidFill>
+          <a:ln>
+            <a:noFill/>
+          </a:ln>
+        </p:spPr>
+        <p:style>
+          <a:lnRef idx="1">
+            <a:schemeClr val="accent1"/>
+          </a:lnRef>
+          <a:fillRef idx="3">
+            <a:schemeClr val="accent1"/>
+          </a:fillRef>
+          <a:effectRef idx="2">
+            <a:schemeClr val="accent1"/>
+          </a:effectRef>
+          <a:fontRef idx="minor">
+            <a:schemeClr val="lt1"/>
+          </a:fontRef>
+        </p:style>
+        <p:txBody>
+          <a:bodyPr rtlCol="0" anchor="ctr"/>
+          <a:lstStyle/>
+          <a:p>
+            <a:pPr algn="ctr"/>
+          </a:p>
+        </p:txBody>
+      </p:sp>
+      <p:sp>
+        <p:nvSpPr>
+          <p:cNvPr id="9" name="Rectangle 8"/>
+          <p:cNvSpPr/>
+          <p:nvPr/>
+        </p:nvSpPr>
+        <p:spPr>
+          <a:xfrm>
+            <a:off x="3291840" y="1325880"/>
+            <a:ext cx="8595360" cy="658368"/>
+          </a:xfrm>
+          <a:prstGeom prst="rect">
+            <a:avLst/>
+          </a:prstGeom>
+          <a:solidFill>
+            <a:srgbClr val="ECF0F1"/>
+          </a:solidFill>
+          <a:ln>
+            <a:noFill/>
+          </a:ln>
+        </p:spPr>
+        <p:style>
+          <a:lnRef idx="1">
+            <a:schemeClr val="accent1"/>
+          </a:lnRef>
+          <a:fillRef idx="3">
+            <a:schemeClr val="accent1"/>
+          </a:fillRef>
+          <a:effectRef idx="2">
+            <a:schemeClr val="accent1"/>
+          </a:effectRef>
+          <a:fontRef idx="minor">
+            <a:schemeClr val="lt1"/>
+          </a:fontRef>
+        </p:style>
+        <p:txBody>
+          <a:bodyPr rtlCol="0" anchor="ctr"/>
+          <a:lstStyle/>
+          <a:p>
+            <a:pPr algn="ctr"/>
+          </a:p>
+        </p:txBody>
+      </p:sp>
+      <p:sp>
+        <p:nvSpPr>
+          <p:cNvPr id="10" name="TextBox 9"/>
+          <p:cNvSpPr txBox="1"/>
+          <p:nvPr/>
+        </p:nvSpPr>
+        <p:spPr>
+          <a:xfrm>
+            <a:off x="347472" y="1362456"/>
+            <a:ext cx="2788920" cy="603503"/>
+          </a:xfrm>
+          <a:prstGeom prst="rect">
+            <a:avLst/>
+          </a:prstGeom>
+          <a:noFill/>
+        </p:spPr>
+        <p:txBody>
+          <a:bodyPr wrap="square">
+            <a:spAutoFit/>
+          </a:bodyPr>
+          <a:lstStyle/>
+          <a:p>
+            <a:pPr algn="l"/>
+            <a:r>
+              <a:rPr sz="900" b="1">
+                <a:solidFill>
+                  <a:srgbClr val="2C3E50"/>
+                </a:solidFill>
+              </a:rPr>
+              <a:t>Versionierung</a:t>
+            </a:r>
+          </a:p>
+        </p:txBody>
+      </p:sp>
+      <p:sp>
+        <p:nvSpPr>
+          <p:cNvPr id="11" name="TextBox 10"/>
+          <p:cNvSpPr txBox="1"/>
+          <p:nvPr/>
+        </p:nvSpPr>
+        <p:spPr>
+          <a:xfrm>
+            <a:off x="3364992" y="1362456"/>
+            <a:ext cx="8412480" cy="603503"/>
+          </a:xfrm>
+          <a:prstGeom prst="rect">
+            <a:avLst/>
+          </a:prstGeom>
+          <a:noFill/>
+        </p:spPr>
+        <p:txBody>
+          <a:bodyPr wrap="square">
+            <a:spAutoFit/>
+          </a:bodyPr>
+          <a:lstStyle/>
+          <a:p>
+            <a:pPr algn="l"/>
+            <a:r>
+              <a:rPr sz="900" b="0">
+                <a:solidFill>
+                  <a:srgbClr val="2C3E50"/>
+                </a:solidFill>
+              </a:rPr>
+              <a:t>SemVer ab v0.2.0; zentrale version.py wird von allen GUIs und den Manuals gelesen; aktuell v0.8.4</a:t>
+            </a:r>
+          </a:p>
+        </p:txBody>
+      </p:sp>
+      <p:sp>
+        <p:nvSpPr>
+          <p:cNvPr id="12" name="Rectangle 11"/>
+          <p:cNvSpPr/>
+          <p:nvPr/>
+        </p:nvSpPr>
+        <p:spPr>
+          <a:xfrm>
+            <a:off x="274320" y="1984248"/>
+            <a:ext cx="2926080" cy="658368"/>
+          </a:xfrm>
+          <a:prstGeom prst="rect">
+            <a:avLst/>
+          </a:prstGeom>
+          <a:solidFill>
+            <a:srgbClr val="FFFFFF"/>
+          </a:solidFill>
+          <a:ln>
+            <a:noFill/>
+          </a:ln>
+        </p:spPr>
+        <p:style>
+          <a:lnRef idx="1">
+            <a:schemeClr val="accent1"/>
+          </a:lnRef>
+          <a:fillRef idx="3">
+            <a:schemeClr val="accent1"/>
+          </a:fillRef>
+          <a:effectRef idx="2">
+            <a:schemeClr val="accent1"/>
+          </a:effectRef>
+          <a:fontRef idx="minor">
+            <a:schemeClr val="lt1"/>
+          </a:fontRef>
+        </p:style>
+        <p:txBody>
+          <a:bodyPr rtlCol="0" anchor="ctr"/>
+          <a:lstStyle/>
+          <a:p>
+            <a:pPr algn="ctr"/>
+          </a:p>
+        </p:txBody>
+      </p:sp>
+      <p:sp>
+        <p:nvSpPr>
+          <p:cNvPr id="13" name="Rectangle 12"/>
+          <p:cNvSpPr/>
+          <p:nvPr/>
+        </p:nvSpPr>
+        <p:spPr>
+          <a:xfrm>
+            <a:off x="3291840" y="1984248"/>
+            <a:ext cx="8595360" cy="658368"/>
+          </a:xfrm>
+          <a:prstGeom prst="rect">
+            <a:avLst/>
+          </a:prstGeom>
+          <a:solidFill>
+            <a:srgbClr val="FFFFFF"/>
+          </a:solidFill>
+          <a:ln>
+            <a:noFill/>
+          </a:ln>
+        </p:spPr>
+        <p:style>
+          <a:lnRef idx="1">
+            <a:schemeClr val="accent1"/>
+          </a:lnRef>
+          <a:fillRef idx="3">
+            <a:schemeClr val="accent1"/>
+          </a:fillRef>
+          <a:effectRef idx="2">
+            <a:schemeClr val="accent1"/>
+          </a:effectRef>
+          <a:fontRef idx="minor">
+            <a:schemeClr val="lt1"/>
+          </a:fontRef>
+        </p:style>
+        <p:txBody>
+          <a:bodyPr rtlCol="0" anchor="ctr"/>
+          <a:lstStyle/>
+          <a:p>
+            <a:pPr algn="ctr"/>
+          </a:p>
+        </p:txBody>
+      </p:sp>
+      <p:sp>
+        <p:nvSpPr>
+          <p:cNvPr id="14" name="TextBox 13"/>
+          <p:cNvSpPr txBox="1"/>
+          <p:nvPr/>
+        </p:nvSpPr>
+        <p:spPr>
+          <a:xfrm>
+            <a:off x="347472" y="2020824"/>
+            <a:ext cx="2788920" cy="603503"/>
+          </a:xfrm>
+          <a:prstGeom prst="rect">
+            <a:avLst/>
+          </a:prstGeom>
+          <a:noFill/>
+        </p:spPr>
+        <p:txBody>
+          <a:bodyPr wrap="square">
+            <a:spAutoFit/>
+          </a:bodyPr>
+          <a:lstStyle/>
+          <a:p>
+            <a:pPr algn="l"/>
+            <a:r>
+              <a:rPr sz="900" b="1">
+                <a:solidFill>
+                  <a:srgbClr val="2C3E50"/>
+                </a:solidFill>
+              </a:rPr>
+              <a:t>Sprachauswahl</a:t>
+            </a:r>
+          </a:p>
+        </p:txBody>
+      </p:sp>
+      <p:sp>
+        <p:nvSpPr>
+          <p:cNvPr id="15" name="TextBox 14"/>
+          <p:cNvSpPr txBox="1"/>
+          <p:nvPr/>
+        </p:nvSpPr>
+        <p:spPr>
+          <a:xfrm>
+            <a:off x="3364992" y="2020824"/>
+            <a:ext cx="8412480" cy="603503"/>
+          </a:xfrm>
+          <a:prstGeom prst="rect">
+            <a:avLst/>
+          </a:prstGeom>
+          <a:noFill/>
+        </p:spPr>
+        <p:txBody>
+          <a:bodyPr wrap="square">
+            <a:spAutoFit/>
+          </a:bodyPr>
+          <a:lstStyle/>
+          <a:p>
+            <a:pPr algn="l"/>
+            <a:r>
+              <a:rPr sz="900" b="0">
+                <a:solidFill>
+                  <a:srgbClr val="2C3E50"/>
+                </a:solidFill>
+              </a:rPr>
+              <a:t>Launcher: DE/EN/RO/PT/FR (5 Sprachen); build_reports und transform_data: DE/EN; letzte Wahl persistent in ~/.situation_report/prefs.json</a:t>
+            </a:r>
+          </a:p>
+        </p:txBody>
+      </p:sp>
+      <p:sp>
+        <p:nvSpPr>
+          <p:cNvPr id="16" name="Rectangle 15"/>
+          <p:cNvSpPr/>
+          <p:nvPr/>
+        </p:nvSpPr>
+        <p:spPr>
+          <a:xfrm>
+            <a:off x="274320" y="2642615"/>
+            <a:ext cx="2926080" cy="658368"/>
+          </a:xfrm>
+          <a:prstGeom prst="rect">
+            <a:avLst/>
+          </a:prstGeom>
+          <a:solidFill>
+            <a:srgbClr val="ECF0F1"/>
+          </a:solidFill>
+          <a:ln>
+            <a:noFill/>
+          </a:ln>
+        </p:spPr>
+        <p:style>
+          <a:lnRef idx="1">
+            <a:schemeClr val="accent1"/>
+          </a:lnRef>
+          <a:fillRef idx="3">
+            <a:schemeClr val="accent1"/>
+          </a:fillRef>
+          <a:effectRef idx="2">
+            <a:schemeClr val="accent1"/>
+          </a:effectRef>
+          <a:fontRef idx="minor">
+            <a:schemeClr val="lt1"/>
+          </a:fontRef>
+        </p:style>
+        <p:txBody>
+          <a:bodyPr rtlCol="0" anchor="ctr"/>
+          <a:lstStyle/>
+          <a:p>
+            <a:pPr algn="ctr"/>
+          </a:p>
+        </p:txBody>
+      </p:sp>
+      <p:sp>
+        <p:nvSpPr>
+          <p:cNvPr id="17" name="Rectangle 16"/>
+          <p:cNvSpPr/>
+          <p:nvPr/>
+        </p:nvSpPr>
+        <p:spPr>
+          <a:xfrm>
+            <a:off x="3291840" y="2642615"/>
+            <a:ext cx="8595360" cy="658368"/>
+          </a:xfrm>
+          <a:prstGeom prst="rect">
+            <a:avLst/>
+          </a:prstGeom>
+          <a:solidFill>
+            <a:srgbClr val="ECF0F1"/>
+          </a:solidFill>
+          <a:ln>
+            <a:noFill/>
+          </a:ln>
+        </p:spPr>
+        <p:style>
+          <a:lnRef idx="1">
+            <a:schemeClr val="accent1"/>
+          </a:lnRef>
+          <a:fillRef idx="3">
+            <a:schemeClr val="accent1"/>
+          </a:fillRef>
+          <a:effectRef idx="2">
+            <a:schemeClr val="accent1"/>
+          </a:effectRef>
+          <a:fontRef idx="minor">
+            <a:schemeClr val="lt1"/>
+          </a:fontRef>
+        </p:style>
+        <p:txBody>
+          <a:bodyPr rtlCol="0" anchor="ctr"/>
+          <a:lstStyle/>
+          <a:p>
+            <a:pPr algn="ctr"/>
+          </a:p>
+        </p:txBody>
+      </p:sp>
+      <p:sp>
+        <p:nvSpPr>
+          <p:cNvPr id="18" name="TextBox 17"/>
+          <p:cNvSpPr txBox="1"/>
+          <p:nvPr/>
+        </p:nvSpPr>
+        <p:spPr>
+          <a:xfrm>
+            <a:off x="347472" y="2679191"/>
+            <a:ext cx="2788920" cy="603503"/>
+          </a:xfrm>
+          <a:prstGeom prst="rect">
+            <a:avLst/>
+          </a:prstGeom>
+          <a:noFill/>
+        </p:spPr>
+        <p:txBody>
+          <a:bodyPr wrap="square">
+            <a:spAutoFit/>
+          </a:bodyPr>
+          <a:lstStyle/>
+          <a:p>
+            <a:pPr algn="l"/>
+            <a:r>
+              <a:rPr sz="900" b="1">
+                <a:solidFill>
+                  <a:srgbClr val="2C3E50"/>
+                </a:solidFill>
+              </a:rPr>
+              <a:t>PDF-Manuals</a:t>
+            </a:r>
+          </a:p>
+        </p:txBody>
+      </p:sp>
+      <p:sp>
+        <p:nvSpPr>
+          <p:cNvPr id="19" name="TextBox 18"/>
+          <p:cNvSpPr txBox="1"/>
+          <p:nvPr/>
+        </p:nvSpPr>
+        <p:spPr>
+          <a:xfrm>
+            <a:off x="3364992" y="2679191"/>
+            <a:ext cx="8412480" cy="603503"/>
+          </a:xfrm>
+          <a:prstGeom prst="rect">
+            <a:avLst/>
+          </a:prstGeom>
+          <a:noFill/>
+        </p:spPr>
+        <p:txBody>
+          <a:bodyPr wrap="square">
+            <a:spAutoFit/>
+          </a:bodyPr>
+          <a:lstStyle/>
+          <a:p>
+            <a:pPr algn="l"/>
+            <a:r>
+              <a:rPr sz="900" b="0">
+                <a:solidFill>
+                  <a:srgbClr val="2C3E50"/>
+                </a:solidFill>
+              </a:rPr>
+              <a:t>Launcher-Handbuch in 5 Sprachen (DE, EN, RO, PT, FR); build_reports und transform_data je DE + EN; generiert mit ReportLab</a:t>
+            </a:r>
+          </a:p>
+        </p:txBody>
+      </p:sp>
+      <p:sp>
+        <p:nvSpPr>
+          <p:cNvPr id="20" name="Rectangle 19"/>
+          <p:cNvSpPr/>
+          <p:nvPr/>
+        </p:nvSpPr>
+        <p:spPr>
+          <a:xfrm>
+            <a:off x="274320" y="3300983"/>
+            <a:ext cx="2926080" cy="658368"/>
+          </a:xfrm>
+          <a:prstGeom prst="rect">
+            <a:avLst/>
+          </a:prstGeom>
+          <a:solidFill>
+            <a:srgbClr val="FFFFFF"/>
+          </a:solidFill>
+          <a:ln>
+            <a:noFill/>
+          </a:ln>
+        </p:spPr>
+        <p:style>
+          <a:lnRef idx="1">
+            <a:schemeClr val="accent1"/>
+          </a:lnRef>
+          <a:fillRef idx="3">
+            <a:schemeClr val="accent1"/>
+          </a:fillRef>
+          <a:effectRef idx="2">
+            <a:schemeClr val="accent1"/>
+          </a:effectRef>
+          <a:fontRef idx="minor">
+            <a:schemeClr val="lt1"/>
+          </a:fontRef>
+        </p:style>
+        <p:txBody>
+          <a:bodyPr rtlCol="0" anchor="ctr"/>
+          <a:lstStyle/>
+          <a:p>
+            <a:pPr algn="ctr"/>
+          </a:p>
+        </p:txBody>
+      </p:sp>
+      <p:sp>
+        <p:nvSpPr>
+          <p:cNvPr id="21" name="Rectangle 20"/>
+          <p:cNvSpPr/>
+          <p:nvPr/>
+        </p:nvSpPr>
+        <p:spPr>
+          <a:xfrm>
+            <a:off x="3291840" y="3300983"/>
+            <a:ext cx="8595360" cy="658368"/>
+          </a:xfrm>
+          <a:prstGeom prst="rect">
+            <a:avLst/>
+          </a:prstGeom>
+          <a:solidFill>
+            <a:srgbClr val="FFFFFF"/>
+          </a:solidFill>
+          <a:ln>
+            <a:noFill/>
+          </a:ln>
+        </p:spPr>
+        <p:style>
+          <a:lnRef idx="1">
+            <a:schemeClr val="accent1"/>
+          </a:lnRef>
+          <a:fillRef idx="3">
+            <a:schemeClr val="accent1"/>
+          </a:fillRef>
+          <a:effectRef idx="2">
+            <a:schemeClr val="accent1"/>
+          </a:effectRef>
+          <a:fontRef idx="minor">
+            <a:schemeClr val="lt1"/>
+          </a:fontRef>
+        </p:style>
+        <p:txBody>
+          <a:bodyPr rtlCol="0" anchor="ctr"/>
+          <a:lstStyle/>
+          <a:p>
+            <a:pPr algn="ctr"/>
+          </a:p>
+        </p:txBody>
+      </p:sp>
+      <p:sp>
+        <p:nvSpPr>
+          <p:cNvPr id="22" name="TextBox 21"/>
+          <p:cNvSpPr txBox="1"/>
+          <p:nvPr/>
+        </p:nvSpPr>
+        <p:spPr>
+          <a:xfrm>
+            <a:off x="347472" y="3337559"/>
+            <a:ext cx="2788920" cy="603503"/>
+          </a:xfrm>
+          <a:prstGeom prst="rect">
+            <a:avLst/>
+          </a:prstGeom>
+          <a:noFill/>
+        </p:spPr>
+        <p:txBody>
+          <a:bodyPr wrap="square">
+            <a:spAutoFit/>
+          </a:bodyPr>
+          <a:lstStyle/>
+          <a:p>
+            <a:pPr algn="l"/>
+            <a:r>
+              <a:rPr sz="900" b="1">
+                <a:solidFill>
+                  <a:srgbClr val="2C3E50"/>
+                </a:solidFill>
+              </a:rPr>
+              <a:t>Manual-Link in GUI</a:t>
+            </a:r>
+          </a:p>
+        </p:txBody>
+      </p:sp>
+      <p:sp>
+        <p:nvSpPr>
+          <p:cNvPr id="23" name="TextBox 22"/>
+          <p:cNvSpPr txBox="1"/>
+          <p:nvPr/>
+        </p:nvSpPr>
+        <p:spPr>
+          <a:xfrm>
+            <a:off x="3364992" y="3337559"/>
+            <a:ext cx="8412480" cy="603503"/>
+          </a:xfrm>
+          <a:prstGeom prst="rect">
+            <a:avLst/>
+          </a:prstGeom>
+          <a:noFill/>
+        </p:spPr>
+        <p:txBody>
+          <a:bodyPr wrap="square">
+            <a:spAutoFit/>
+          </a:bodyPr>
+          <a:lstStyle/>
+          <a:p>
+            <a:pPr algn="l"/>
+            <a:r>
+              <a:rPr sz="900" b="0">
+                <a:solidFill>
+                  <a:srgbClr val="2C3E50"/>
+                </a:solidFill>
+              </a:rPr>
+              <a:t>Hilfe-Menü / (?)-Button öffnet das sprachpassende PDF direkt auf GitHub Pages</a:t>
+            </a:r>
+          </a:p>
+        </p:txBody>
+      </p:sp>
+      <p:sp>
+        <p:nvSpPr>
+          <p:cNvPr id="24" name="Rectangle 23"/>
+          <p:cNvSpPr/>
+          <p:nvPr/>
+        </p:nvSpPr>
+        <p:spPr>
+          <a:xfrm>
+            <a:off x="274320" y="3959351"/>
+            <a:ext cx="2926080" cy="658368"/>
+          </a:xfrm>
+          <a:prstGeom prst="rect">
+            <a:avLst/>
+          </a:prstGeom>
+          <a:solidFill>
+            <a:srgbClr val="ECF0F1"/>
+          </a:solidFill>
+          <a:ln>
+            <a:noFill/>
+          </a:ln>
+        </p:spPr>
+        <p:style>
+          <a:lnRef idx="1">
+            <a:schemeClr val="accent1"/>
+          </a:lnRef>
+          <a:fillRef idx="3">
+            <a:schemeClr val="accent1"/>
+          </a:fillRef>
+          <a:effectRef idx="2">
+            <a:schemeClr val="accent1"/>
+          </a:effectRef>
+          <a:fontRef idx="minor">
+            <a:schemeClr val="lt1"/>
+          </a:fontRef>
+        </p:style>
+        <p:txBody>
+          <a:bodyPr rtlCol="0" anchor="ctr"/>
+          <a:lstStyle/>
+          <a:p>
+            <a:pPr algn="ctr"/>
+          </a:p>
+        </p:txBody>
+      </p:sp>
+      <p:sp>
+        <p:nvSpPr>
+          <p:cNvPr id="25" name="Rectangle 24"/>
+          <p:cNvSpPr/>
+          <p:nvPr/>
+        </p:nvSpPr>
+        <p:spPr>
+          <a:xfrm>
+            <a:off x="3291840" y="3959351"/>
+            <a:ext cx="8595360" cy="658368"/>
+          </a:xfrm>
+          <a:prstGeom prst="rect">
+            <a:avLst/>
+          </a:prstGeom>
+          <a:solidFill>
+            <a:srgbClr val="ECF0F1"/>
+          </a:solidFill>
+          <a:ln>
+            <a:noFill/>
+          </a:ln>
+        </p:spPr>
+        <p:style>
+          <a:lnRef idx="1">
+            <a:schemeClr val="accent1"/>
+          </a:lnRef>
+          <a:fillRef idx="3">
+            <a:schemeClr val="accent1"/>
+          </a:fillRef>
+          <a:effectRef idx="2">
+            <a:schemeClr val="accent1"/>
+          </a:effectRef>
+          <a:fontRef idx="minor">
+            <a:schemeClr val="lt1"/>
+          </a:fontRef>
+        </p:style>
+        <p:txBody>
+          <a:bodyPr rtlCol="0" anchor="ctr"/>
+          <a:lstStyle/>
+          <a:p>
+            <a:pPr algn="ctr"/>
+          </a:p>
+        </p:txBody>
+      </p:sp>
+      <p:sp>
+        <p:nvSpPr>
+          <p:cNvPr id="26" name="TextBox 25"/>
+          <p:cNvSpPr txBox="1"/>
+          <p:nvPr/>
+        </p:nvSpPr>
+        <p:spPr>
+          <a:xfrm>
+            <a:off x="347472" y="3995927"/>
+            <a:ext cx="2788920" cy="603503"/>
+          </a:xfrm>
+          <a:prstGeom prst="rect">
+            <a:avLst/>
+          </a:prstGeom>
+          <a:noFill/>
+        </p:spPr>
+        <p:txBody>
+          <a:bodyPr wrap="square">
+            <a:spAutoFit/>
+          </a:bodyPr>
+          <a:lstStyle/>
+          <a:p>
+            <a:pPr algn="l"/>
+            <a:r>
+              <a:rPr sz="900" b="1">
+                <a:solidFill>
+                  <a:srgbClr val="2C3E50"/>
+                </a:solidFill>
+              </a:rPr>
+              <a:t>GitHub Pages Doku</a:t>
+            </a:r>
+          </a:p>
+        </p:txBody>
+      </p:sp>
+      <p:sp>
+        <p:nvSpPr>
+          <p:cNvPr id="27" name="TextBox 26"/>
+          <p:cNvSpPr txBox="1"/>
+          <p:nvPr/>
+        </p:nvSpPr>
+        <p:spPr>
+          <a:xfrm>
+            <a:off x="3364992" y="3995927"/>
+            <a:ext cx="8412480" cy="603503"/>
+          </a:xfrm>
+          <a:prstGeom prst="rect">
+            <a:avLst/>
+          </a:prstGeom>
+          <a:noFill/>
+        </p:spPr>
+        <p:txBody>
+          <a:bodyPr wrap="square">
+            <a:spAutoFit/>
+          </a:bodyPr>
+          <a:lstStyle/>
+          <a:p>
+            <a:pPr algn="l"/>
+            <a:r>
+              <a:rPr sz="900" b="0">
+                <a:solidFill>
+                  <a:srgbClr val="2C3E50"/>
+                </a:solidFill>
+              </a:rPr>
+              <a:t>MkDocs-Site mit DE/EN-Doku für alle Module; Architektur nach C4-Modell</a:t>
+            </a:r>
+          </a:p>
+        </p:txBody>
+      </p:sp>
+      <p:sp>
+        <p:nvSpPr>
+          <p:cNvPr id="28" name="Rectangle 27"/>
+          <p:cNvSpPr/>
+          <p:nvPr/>
+        </p:nvSpPr>
+        <p:spPr>
+          <a:xfrm>
+            <a:off x="274320" y="4617719"/>
+            <a:ext cx="2926080" cy="658368"/>
+          </a:xfrm>
+          <a:prstGeom prst="rect">
+            <a:avLst/>
+          </a:prstGeom>
+          <a:solidFill>
+            <a:srgbClr val="FFFFFF"/>
+          </a:solidFill>
+          <a:ln>
+            <a:noFill/>
+          </a:ln>
+        </p:spPr>
+        <p:style>
+          <a:lnRef idx="1">
+            <a:schemeClr val="accent1"/>
+          </a:lnRef>
+          <a:fillRef idx="3">
+            <a:schemeClr val="accent1"/>
+          </a:fillRef>
+          <a:effectRef idx="2">
+            <a:schemeClr val="accent1"/>
+          </a:effectRef>
+          <a:fontRef idx="minor">
+            <a:schemeClr val="lt1"/>
+          </a:fontRef>
+        </p:style>
+        <p:txBody>
+          <a:bodyPr rtlCol="0" anchor="ctr"/>
+          <a:lstStyle/>
+          <a:p>
+            <a:pPr algn="ctr"/>
+          </a:p>
+        </p:txBody>
+      </p:sp>
+      <p:sp>
+        <p:nvSpPr>
+          <p:cNvPr id="29" name="Rectangle 28"/>
+          <p:cNvSpPr/>
+          <p:nvPr/>
+        </p:nvSpPr>
+        <p:spPr>
+          <a:xfrm>
+            <a:off x="3291840" y="4617719"/>
+            <a:ext cx="8595360" cy="658368"/>
+          </a:xfrm>
+          <a:prstGeom prst="rect">
+            <a:avLst/>
+          </a:prstGeom>
+          <a:solidFill>
+            <a:srgbClr val="FFFFFF"/>
+          </a:solidFill>
+          <a:ln>
+            <a:noFill/>
+          </a:ln>
+        </p:spPr>
+        <p:style>
+          <a:lnRef idx="1">
+            <a:schemeClr val="accent1"/>
+          </a:lnRef>
+          <a:fillRef idx="3">
+            <a:schemeClr val="accent1"/>
+          </a:fillRef>
+          <a:effectRef idx="2">
+            <a:schemeClr val="accent1"/>
+          </a:effectRef>
+          <a:fontRef idx="minor">
+            <a:schemeClr val="lt1"/>
+          </a:fontRef>
+        </p:style>
+        <p:txBody>
+          <a:bodyPr rtlCol="0" anchor="ctr"/>
+          <a:lstStyle/>
+          <a:p>
+            <a:pPr algn="ctr"/>
+          </a:p>
+        </p:txBody>
+      </p:sp>
+      <p:sp>
+        <p:nvSpPr>
+          <p:cNvPr id="30" name="TextBox 29"/>
+          <p:cNvSpPr txBox="1"/>
+          <p:nvPr/>
+        </p:nvSpPr>
+        <p:spPr>
+          <a:xfrm>
+            <a:off x="347472" y="4654295"/>
+            <a:ext cx="2788920" cy="603503"/>
+          </a:xfrm>
+          <a:prstGeom prst="rect">
+            <a:avLst/>
+          </a:prstGeom>
+          <a:noFill/>
+        </p:spPr>
+        <p:txBody>
+          <a:bodyPr wrap="square">
+            <a:spAutoFit/>
+          </a:bodyPr>
+          <a:lstStyle/>
+          <a:p>
+            <a:pPr algn="l"/>
+            <a:r>
+              <a:rPr sz="900" b="1">
+                <a:solidFill>
+                  <a:srgbClr val="2C3E50"/>
+                </a:solidFill>
+              </a:rPr>
+              <a:t>CI/CD</a:t>
+            </a:r>
+          </a:p>
+        </p:txBody>
+      </p:sp>
+      <p:sp>
+        <p:nvSpPr>
+          <p:cNvPr id="31" name="TextBox 30"/>
+          <p:cNvSpPr txBox="1"/>
+          <p:nvPr/>
+        </p:nvSpPr>
+        <p:spPr>
+          <a:xfrm>
+            <a:off x="3364992" y="4654295"/>
+            <a:ext cx="8412480" cy="603503"/>
+          </a:xfrm>
+          <a:prstGeom prst="rect">
+            <a:avLst/>
+          </a:prstGeom>
+          <a:noFill/>
+        </p:spPr>
+        <p:txBody>
+          <a:bodyPr wrap="square">
+            <a:spAutoFit/>
+          </a:bodyPr>
+          <a:lstStyle/>
+          <a:p>
+            <a:pPr algn="l"/>
+            <a:r>
+              <a:rPr sz="900" b="0">
+                <a:solidFill>
+                  <a:srgbClr val="2C3E50"/>
+                </a:solidFill>
+              </a:rPr>
+              <a:t>GitHub Actions für automatisches Docs-Deployment und Release-Erstellung bei v*-Tags</a:t>
+            </a:r>
+          </a:p>
+        </p:txBody>
+      </p:sp>
+      <p:sp>
+        <p:nvSpPr>
+          <p:cNvPr id="32" name="Rectangle 31"/>
+          <p:cNvSpPr/>
+          <p:nvPr/>
+        </p:nvSpPr>
+        <p:spPr>
+          <a:xfrm>
+            <a:off x="274320" y="5276087"/>
+            <a:ext cx="2926080" cy="658368"/>
+          </a:xfrm>
+          <a:prstGeom prst="rect">
+            <a:avLst/>
+          </a:prstGeom>
+          <a:solidFill>
+            <a:srgbClr val="ECF0F1"/>
+          </a:solidFill>
+          <a:ln>
+            <a:noFill/>
+          </a:ln>
+        </p:spPr>
+        <p:style>
+          <a:lnRef idx="1">
+            <a:schemeClr val="accent1"/>
+          </a:lnRef>
+          <a:fillRef idx="3">
+            <a:schemeClr val="accent1"/>
+          </a:fillRef>
+          <a:effectRef idx="2">
+            <a:schemeClr val="accent1"/>
+          </a:effectRef>
+          <a:fontRef idx="minor">
+            <a:schemeClr val="lt1"/>
+          </a:fontRef>
+        </p:style>
+        <p:txBody>
+          <a:bodyPr rtlCol="0" anchor="ctr"/>
+          <a:lstStyle/>
+          <a:p>
+            <a:pPr algn="ctr"/>
+          </a:p>
+        </p:txBody>
+      </p:sp>
+      <p:sp>
+        <p:nvSpPr>
+          <p:cNvPr id="33" name="Rectangle 32"/>
+          <p:cNvSpPr/>
+          <p:nvPr/>
+        </p:nvSpPr>
+        <p:spPr>
+          <a:xfrm>
+            <a:off x="3291840" y="5276087"/>
+            <a:ext cx="8595360" cy="658368"/>
+          </a:xfrm>
+          <a:prstGeom prst="rect">
+            <a:avLst/>
+          </a:prstGeom>
+          <a:solidFill>
+            <a:srgbClr val="ECF0F1"/>
+          </a:solidFill>
+          <a:ln>
+            <a:noFill/>
+          </a:ln>
+        </p:spPr>
+        <p:style>
+          <a:lnRef idx="1">
+            <a:schemeClr val="accent1"/>
+          </a:lnRef>
+          <a:fillRef idx="3">
+            <a:schemeClr val="accent1"/>
+          </a:fillRef>
+          <a:effectRef idx="2">
+            <a:schemeClr val="accent1"/>
+          </a:effectRef>
+          <a:fontRef idx="minor">
+            <a:schemeClr val="lt1"/>
+          </a:fontRef>
+        </p:style>
+        <p:txBody>
+          <a:bodyPr rtlCol="0" anchor="ctr"/>
+          <a:lstStyle/>
+          <a:p>
+            <a:pPr algn="ctr"/>
+          </a:p>
+        </p:txBody>
+      </p:sp>
+      <p:sp>
+        <p:nvSpPr>
+          <p:cNvPr id="34" name="TextBox 33"/>
+          <p:cNvSpPr txBox="1"/>
+          <p:nvPr/>
+        </p:nvSpPr>
+        <p:spPr>
+          <a:xfrm>
+            <a:off x="347472" y="5312663"/>
+            <a:ext cx="2788920" cy="603503"/>
+          </a:xfrm>
+          <a:prstGeom prst="rect">
+            <a:avLst/>
+          </a:prstGeom>
+          <a:noFill/>
+        </p:spPr>
+        <p:txBody>
+          <a:bodyPr wrap="square">
+            <a:spAutoFit/>
+          </a:bodyPr>
+          <a:lstStyle/>
+          <a:p>
+            <a:pPr algn="l"/>
+            <a:r>
+              <a:rPr sz="900" b="1">
+                <a:solidFill>
+                  <a:srgbClr val="2C3E50"/>
+                </a:solidFill>
+              </a:rPr>
+              <a:t>Tests</a:t>
+            </a:r>
+          </a:p>
+        </p:txBody>
+      </p:sp>
+      <p:sp>
+        <p:nvSpPr>
+          <p:cNvPr id="35" name="TextBox 34"/>
+          <p:cNvSpPr txBox="1"/>
+          <p:nvPr/>
+        </p:nvSpPr>
+        <p:spPr>
+          <a:xfrm>
+            <a:off x="3364992" y="5312663"/>
+            <a:ext cx="8412480" cy="603503"/>
+          </a:xfrm>
+          <a:prstGeom prst="rect">
+            <a:avLst/>
+          </a:prstGeom>
+          <a:noFill/>
+        </p:spPr>
+        <p:txBody>
+          <a:bodyPr wrap="square">
+            <a:spAutoFit/>
+          </a:bodyPr>
+          <a:lstStyle/>
+          <a:p>
+            <a:pPr algn="l"/>
+            <a:r>
+              <a:rPr sz="900" b="0">
+                <a:solidFill>
+                  <a:srgbClr val="2C3E50"/>
+                </a:solidFill>
+              </a:rPr>
+              <a:t>Unit- und Acceptance-Tests für alle Module; aktuell 542 Tests</a:t>
             </a:r>
           </a:p>
         </p:txBody>

</xml_diff>